<commit_message>
Present bilingual documentation as professional technical material
</commit_message>
<xml_diff>
--- a/presentations/SoIC_Process_Engineer_Briefing_ZH.pptx
+++ b/presentations/SoIC_Process_Engineer_Briefing_ZH.pptx
@@ -2,32 +2,32 @@
 <file path=ppt/presentation.xml><?xml version="1.0" encoding="utf-8"?>
 <p:presentation xmlns:p="http://schemas.openxmlformats.org/presentationml/2006/main">
   <p:sldMasterIdLst>
-    <p:sldMasterId xmlns:r="http://schemas.openxmlformats.org/officeDocument/2006/relationships" id="2147483648" r:id="R5aeb6b152d264755"/>
+    <p:sldMasterId xmlns:r="http://schemas.openxmlformats.org/officeDocument/2006/relationships" id="2147483648" r:id="R0a8d834bc27d4afc"/>
   </p:sldMasterIdLst>
   <p:notesMasterIdLst>
-    <p:notesMasterId xmlns:r="http://schemas.openxmlformats.org/officeDocument/2006/relationships" r:id="R97cb1bddf5f84914"/>
+    <p:notesMasterId xmlns:r="http://schemas.openxmlformats.org/officeDocument/2006/relationships" r:id="R8e2dc6d23dd447fc"/>
   </p:notesMasterIdLst>
   <p:sldIdLst>
-    <p:sldId xmlns:r="http://schemas.openxmlformats.org/officeDocument/2006/relationships" id="256" r:id="R3c73a6073d314efe"/>
-    <p:sldId xmlns:r="http://schemas.openxmlformats.org/officeDocument/2006/relationships" id="257" r:id="R73b6668799424152"/>
-    <p:sldId xmlns:r="http://schemas.openxmlformats.org/officeDocument/2006/relationships" id="258" r:id="R834bd59bafb940d0"/>
-    <p:sldId xmlns:r="http://schemas.openxmlformats.org/officeDocument/2006/relationships" id="259" r:id="Rb94dced37c734940"/>
-    <p:sldId xmlns:r="http://schemas.openxmlformats.org/officeDocument/2006/relationships" id="260" r:id="R3d4866d958f84ef2"/>
-    <p:sldId xmlns:r="http://schemas.openxmlformats.org/officeDocument/2006/relationships" id="261" r:id="R895128e3364d4bb4"/>
-    <p:sldId xmlns:r="http://schemas.openxmlformats.org/officeDocument/2006/relationships" id="262" r:id="R1dd033d84ac44349"/>
-    <p:sldId xmlns:r="http://schemas.openxmlformats.org/officeDocument/2006/relationships" id="263" r:id="R1c7cfdbe666b4c89"/>
-    <p:sldId xmlns:r="http://schemas.openxmlformats.org/officeDocument/2006/relationships" id="264" r:id="Rcf8f5581d6574ac7"/>
-    <p:sldId xmlns:r="http://schemas.openxmlformats.org/officeDocument/2006/relationships" id="265" r:id="R177fceea0dfe47af"/>
-    <p:sldId xmlns:r="http://schemas.openxmlformats.org/officeDocument/2006/relationships" id="266" r:id="R0afb5c32ccb24506"/>
-    <p:sldId xmlns:r="http://schemas.openxmlformats.org/officeDocument/2006/relationships" id="267" r:id="R50c7662b81c94ed9"/>
-    <p:sldId xmlns:r="http://schemas.openxmlformats.org/officeDocument/2006/relationships" id="268" r:id="R689469bd86754765"/>
-    <p:sldId xmlns:r="http://schemas.openxmlformats.org/officeDocument/2006/relationships" id="269" r:id="Rc74dab165d5b4b58"/>
-    <p:sldId xmlns:r="http://schemas.openxmlformats.org/officeDocument/2006/relationships" id="270" r:id="Rf5970db5977c4666"/>
-    <p:sldId xmlns:r="http://schemas.openxmlformats.org/officeDocument/2006/relationships" id="271" r:id="R6d12219136e9433e"/>
-    <p:sldId xmlns:r="http://schemas.openxmlformats.org/officeDocument/2006/relationships" id="272" r:id="Rae186a68671646c0"/>
-    <p:sldId xmlns:r="http://schemas.openxmlformats.org/officeDocument/2006/relationships" id="273" r:id="Rcd34dd7f3f8b4897"/>
-    <p:sldId xmlns:r="http://schemas.openxmlformats.org/officeDocument/2006/relationships" id="274" r:id="Rd7f3705dd5b641d1"/>
-    <p:sldId xmlns:r="http://schemas.openxmlformats.org/officeDocument/2006/relationships" id="275" r:id="R9a88b49aeea84f1c"/>
+    <p:sldId xmlns:r="http://schemas.openxmlformats.org/officeDocument/2006/relationships" id="256" r:id="Raa2ce5256962493c"/>
+    <p:sldId xmlns:r="http://schemas.openxmlformats.org/officeDocument/2006/relationships" id="257" r:id="Rbe3f773275d149aa"/>
+    <p:sldId xmlns:r="http://schemas.openxmlformats.org/officeDocument/2006/relationships" id="258" r:id="R576a90f9ba474f6d"/>
+    <p:sldId xmlns:r="http://schemas.openxmlformats.org/officeDocument/2006/relationships" id="259" r:id="R179f8630317647a8"/>
+    <p:sldId xmlns:r="http://schemas.openxmlformats.org/officeDocument/2006/relationships" id="260" r:id="R372913c6caee4214"/>
+    <p:sldId xmlns:r="http://schemas.openxmlformats.org/officeDocument/2006/relationships" id="261" r:id="R68e37dd0133d47dd"/>
+    <p:sldId xmlns:r="http://schemas.openxmlformats.org/officeDocument/2006/relationships" id="262" r:id="R02c1bce1b14e4e26"/>
+    <p:sldId xmlns:r="http://schemas.openxmlformats.org/officeDocument/2006/relationships" id="263" r:id="Ree59159395dd41d1"/>
+    <p:sldId xmlns:r="http://schemas.openxmlformats.org/officeDocument/2006/relationships" id="264" r:id="R55f2f7a7de3a4ca7"/>
+    <p:sldId xmlns:r="http://schemas.openxmlformats.org/officeDocument/2006/relationships" id="265" r:id="R520d9c6e88e84162"/>
+    <p:sldId xmlns:r="http://schemas.openxmlformats.org/officeDocument/2006/relationships" id="266" r:id="R8cb6c4b1d01e45df"/>
+    <p:sldId xmlns:r="http://schemas.openxmlformats.org/officeDocument/2006/relationships" id="267" r:id="R172f8a07523c4691"/>
+    <p:sldId xmlns:r="http://schemas.openxmlformats.org/officeDocument/2006/relationships" id="268" r:id="R8bf3d88908d74d28"/>
+    <p:sldId xmlns:r="http://schemas.openxmlformats.org/officeDocument/2006/relationships" id="269" r:id="R59a1af25a89847b8"/>
+    <p:sldId xmlns:r="http://schemas.openxmlformats.org/officeDocument/2006/relationships" id="270" r:id="Raf6b849b1212426e"/>
+    <p:sldId xmlns:r="http://schemas.openxmlformats.org/officeDocument/2006/relationships" id="271" r:id="Rc60f99cc038a4f66"/>
+    <p:sldId xmlns:r="http://schemas.openxmlformats.org/officeDocument/2006/relationships" id="272" r:id="R1b3863f27ab940a2"/>
+    <p:sldId xmlns:r="http://schemas.openxmlformats.org/officeDocument/2006/relationships" id="273" r:id="Rb7405502426340d8"/>
+    <p:sldId xmlns:r="http://schemas.openxmlformats.org/officeDocument/2006/relationships" id="274" r:id="Rdd88e959f0d1405e"/>
+    <p:sldId xmlns:r="http://schemas.openxmlformats.org/officeDocument/2006/relationships" id="275" r:id="Rba9f13dde4254ef4"/>
   </p:sldIdLst>
   <p:sldSz cx="12192000" cy="6858000"/>
   <p:notesSz cx="6858000" cy="9144000"/>
@@ -461,7 +461,7 @@
           <a:lstStyle xmlns:a="http://schemas.openxmlformats.org/drawingml/2006/main"/>
           <a:p xmlns:a="http://schemas.openxmlformats.org/drawingml/2006/main">
             <a:r>
-              <a:t>我以鍵合加工的模擬資料建立缺陷風險排序模型，想回答在檢查容量有限的情況下，如何優先檢查較可能有缺陷的紀錄，並用可追溯的評估與模型解釋提出工程調查方向。</a:t>
+              <a:t>本專題以鍵合加工的模擬資料建立缺陷風險排序模型，研究在檢查容量有限的情況下，如何優先檢查較可能有缺陷的紀錄，並用可追溯的評估與模型解釋提出工程調查方向。</a:t>
             </a:r>
           </a:p>
           <a:p xmlns:a="http://schemas.openxmlformats.org/drawingml/2006/main">
@@ -796,7 +796,7 @@
           <a:lstStyle xmlns:a="http://schemas.openxmlformats.org/drawingml/2006/main"/>
           <a:p xmlns:a="http://schemas.openxmlformats.org/drawingml/2006/main">
             <a:r>
-              <a:t>若高分紀錄集中在某台設備或某時段，我會先核對資料與量測，再分層產品、配方、腔體與維修事件，避免把資料異常當成物理故障。</a:t>
+              <a:t>若高分紀錄集中在某台設備或某時段，需要先核對資料與量測，再分層產品、配方、腔體與維修事件，避免把資料異常當成物理故障。</a:t>
             </a:r>
           </a:p>
           <a:p xmlns:a="http://schemas.openxmlformats.org/drawingml/2006/main">
@@ -886,7 +886,7 @@
           </a:p>
           <a:p xmlns:a="http://schemas.openxmlformats.org/drawingml/2006/main">
             <a:r>
-              <a:t>若要加上 SPC，我會先確認量測系統、穩定基準與合理子群，再依資料性質評估缺陷比例 p-chart 或連續量測管制圖，批次群聚、時間相依與過度離散也要檢查。</a:t>
+              <a:t>若要加上 SPC，需要先確認量測系統、穩定基準與合理子群，再依資料性質評估缺陷比例 p-chart 或連續量測管制圖，批次群聚、時間相依與過度離散也要檢查。</a:t>
             </a:r>
           </a:p>
           <a:p xmlns:a="http://schemas.openxmlformats.org/drawingml/2006/main">
@@ -1056,12 +1056,12 @@
           </a:p>
           <a:p xmlns:a="http://schemas.openxmlformats.org/drawingml/2006/main">
             <a:r>
-              <a:t>我會提供中英文欄位字典、版本、異常案例與復歸紀錄，跨時區交接明確標示目前狀態、待確認事項、Owner 與完成條件。</a:t>
-            </a:r>
-          </a:p>
-          <a:p xmlns:a="http://schemas.openxmlformats.org/drawingml/2006/main">
-            <a:r>
-              <a:t>文件與方法能支持交接，赴美意願、時程與現場能力需本人據實說明，專題不預設承諾。</a:t>
+              <a:t>交接內容包含中英文欄位字典、版本、異常案例與復歸紀錄，跨時區交接明確標示目前狀態、待確認事項、Owner 與完成條件。</a:t>
+            </a:r>
+          </a:p>
+          <a:p xmlns:a="http://schemas.openxmlformats.org/drawingml/2006/main">
+            <a:r>
+              <a:t>文件與方法能支持交接，當地設備與配方條件仍需驗證。</a:t>
             </a:r>
           </a:p>
           <a:p xmlns:a="http://schemas.openxmlformats.org/drawingml/2006/main">
@@ -1141,7 +1141,7 @@
           </a:p>
           <a:p xmlns:a="http://schemas.openxmlformats.org/drawingml/2006/main">
             <a:r>
-              <a:t>我會先補齊單位與標籤定義，取得授權且具代表性的真實資料，再評估更多期間、機台與產品，確認分數校準和缺陷遺漏代價。</a:t>
+              <a:t>需要先補齊單位與標籤定義，取得授權且具代表性的真實資料，再評估更多期間、機台與產品，確認分數校準和缺陷遺漏代價。</a:t>
             </a:r>
           </a:p>
           <a:p xmlns:a="http://schemas.openxmlformats.org/drawingml/2006/main">
@@ -1301,17 +1301,17 @@
           <a:lstStyle xmlns:a="http://schemas.openxmlformats.org/drawingml/2006/main"/>
           <a:p xmlns:a="http://schemas.openxmlformats.org/drawingml/2006/main">
             <a:r>
-              <a:t>如果主管問這是否改善良率，我會說目前證據是選取清單集中更多缺陷，良率需要處置後的獨立結果。</a:t>
-            </a:r>
-          </a:p>
-          <a:p xmlns:a="http://schemas.openxmlformats.org/drawingml/2006/main">
-            <a:r>
-              <a:t>若問最大根因，我會說對準誤差是模型依賴度最高的參數，尚需量測與實驗確認。</a:t>
-            </a:r>
-          </a:p>
-          <a:p xmlns:a="http://schemas.openxmlformats.org/drawingml/2006/main">
-            <a:r>
-              <a:t>若問能否停檢其他晶圓，我會說未選中仍有缺陷，品質政策需要按規範決定。</a:t>
+              <a:t>目前證據是選取清單集中更多缺陷，良率改善需要處置後的獨立結果。</a:t>
+            </a:r>
+          </a:p>
+          <a:p xmlns:a="http://schemas.openxmlformats.org/drawingml/2006/main">
+            <a:r>
+              <a:t>對準誤差是模型依賴度最高的參數，物理根因尚需量測與實驗確認。</a:t>
+            </a:r>
+          </a:p>
+          <a:p xmlns:a="http://schemas.openxmlformats.org/drawingml/2006/main">
+            <a:r>
+              <a:t>未選中紀錄仍有缺陷，品質政策需要依規範決定。</a:t>
             </a:r>
           </a:p>
           <a:p xmlns:a="http://schemas.openxmlformats.org/drawingml/2006/main">
@@ -1386,7 +1386,7 @@
           <a:lstStyle xmlns:a="http://schemas.openxmlformats.org/drawingml/2006/main"/>
           <a:p xmlns:a="http://schemas.openxmlformats.org/drawingml/2006/main">
             <a:r>
-              <a:t>我把問題定義為加工後、品質檢查前的檢查優先排序，因為平均溫度與加工時間等摘要需要在該步驟完成後才可取得。</a:t>
+              <a:t>問題定義為加工後、品質檢查前的檢查優先排序，因為平均溫度與加工時間等摘要需要在該步驟完成後才可取得。</a:t>
             </a:r>
           </a:p>
           <a:p xmlns:a="http://schemas.openxmlformats.org/drawingml/2006/main">
@@ -1471,7 +1471,7 @@
           <a:lstStyle xmlns:a="http://schemas.openxmlformats.org/drawingml/2006/main"/>
           <a:p xmlns:a="http://schemas.openxmlformats.org/drawingml/2006/main">
             <a:r>
-              <a:t>主管可從 GitHub 首頁開啟 Colab，下載固定 CSV 後上傳，依序執行分析格，結果表、模型與圖都在儲存庫。</a:t>
+              <a:t>可從 GitHub 首頁開啟 Colab，下載固定 CSV 後上傳，依序執行分析格，結果表、模型與圖都在儲存庫。</a:t>
             </a:r>
           </a:p>
           <a:p xmlns:a="http://schemas.openxmlformats.org/drawingml/2006/main">
@@ -1556,17 +1556,17 @@
           <a:lstStyle xmlns:a="http://schemas.openxmlformats.org/drawingml/2006/main"/>
           <a:p xmlns:a="http://schemas.openxmlformats.org/drawingml/2006/main">
             <a:r>
-              <a:t>依提供的職缺，工作包含製程開發與維持、設備排查、跨部門溝通與 SPC／DOE，並期待 Python 或 AI 能力。</a:t>
-            </a:r>
-          </a:p>
-          <a:p xmlns:a="http://schemas.openxmlformats.org/drawingml/2006/main">
-            <a:r>
-              <a:t>我把每個分析步驟對應到一個工程問題，並保留證據層級，現有成果支持資料分析，尚未證明現場操作、量產改善或赴美任職準備。</a:t>
-            </a:r>
-          </a:p>
-          <a:p xmlns:a="http://schemas.openxmlformats.org/drawingml/2006/main">
-            <a:r>
-              <a:t>赴美意願與時程應由本人據實回答，這份專題提供的是雙語文件與交接方法。</a:t>
+              <a:t>製程工程應用涵蓋製程開發與維持、設備排查、跨部門溝通與 SPC／DOE，Python 與模型分析可提供資料支持。</a:t>
+            </a:r>
+          </a:p>
+          <a:p xmlns:a="http://schemas.openxmlformats.org/drawingml/2006/main">
+            <a:r>
+              <a:t>每個分析步驟對應到一個工程問題，並保留證據層級，現有成果支持資料分析，現場操作與量產改善需額外驗證。</a:t>
+            </a:r>
+          </a:p>
+          <a:p xmlns:a="http://schemas.openxmlformats.org/drawingml/2006/main">
+            <a:r>
+              <a:t>雙語技術文件與交接方法可支持跨廠協作，現場責任依實際作業規範確認。</a:t>
             </a:r>
           </a:p>
           <a:p xmlns:a="http://schemas.openxmlformats.org/drawingml/2006/main">
@@ -1726,7 +1726,7 @@
           <a:lstStyle xmlns:a="http://schemas.openxmlformats.org/drawingml/2006/main"/>
           <a:p xmlns:a="http://schemas.openxmlformats.org/drawingml/2006/main">
             <a:r>
-              <a:t>我依批次最早時間排序，分成七成訓練、一成五驗證與一成五測試，並檢查各集合的時間範圍沒有重疊。</a:t>
+              <a:t>資料依批次最早時間排序，分成七成訓練、一成五驗證與一成五測試，並檢查各集合的時間範圍沒有重疊。</a:t>
             </a:r>
           </a:p>
           <a:p xmlns:a="http://schemas.openxmlformats.org/drawingml/2006/main">
@@ -1906,7 +1906,7 @@
           </a:p>
           <a:p xmlns:a="http://schemas.openxmlformats.org/drawingml/2006/main">
             <a:r>
-              <a:t>我接著固定相同檢查量比較模型，才能評估排序方法本身的差異。</a:t>
+              <a:t>接著固定相同檢查量比較模型，才能評估排序方法本身的差異。</a:t>
             </a:r>
           </a:p>
           <a:p xmlns:a="http://schemas.openxmlformats.org/drawingml/2006/main">
@@ -2128,7 +2128,7 @@
           <p:cNvPr id="3" name="Title">
             <a:extLst xmlns:a="http://schemas.openxmlformats.org/drawingml/2006/main">
               <a:ext uri="{FF2B5EF4-FFF2-40B4-BE49-F238E27FC236}">
-                <a16:creationId xmlns:a16="http://schemas.microsoft.com/office/drawing/2014/main" id="{094FF24D-0717-4D8D-A494-F736653742AF}"/>
+                <a16:creationId xmlns:a16="http://schemas.microsoft.com/office/drawing/2014/main" id="{37D1A9A8-1E40-4F69-BA6E-7C1794104F23}"/>
               </a:ext>
             </a:extLst>
           </p:cNvPr>
@@ -2285,7 +2285,7 @@
           <p:cNvPr id="2" name="Subtitle">
             <a:extLst xmlns:a="http://schemas.openxmlformats.org/drawingml/2006/main">
               <a:ext uri="{FF2B5EF4-FFF2-40B4-BE49-F238E27FC236}">
-                <a16:creationId xmlns:a16="http://schemas.microsoft.com/office/drawing/2014/main" id="{6997F1FC-8DA7-466B-B86F-24B94E4CCA82}"/>
+                <a16:creationId xmlns:a16="http://schemas.microsoft.com/office/drawing/2014/main" id="{5CE91B01-5483-4019-886C-1EFD39DE3A7B}"/>
               </a:ext>
             </a:extLst>
           </p:cNvPr>
@@ -2459,7 +2459,7 @@
           <p:cNvPr id="2" name="Section title">
             <a:extLst xmlns:a="http://schemas.openxmlformats.org/drawingml/2006/main">
               <a:ext uri="{FF2B5EF4-FFF2-40B4-BE49-F238E27FC236}">
-                <a16:creationId xmlns:a16="http://schemas.microsoft.com/office/drawing/2014/main" id="{89595FB3-AAA2-4995-ACB1-82A804547744}"/>
+                <a16:creationId xmlns:a16="http://schemas.microsoft.com/office/drawing/2014/main" id="{8C483A44-DB60-4A87-A520-399432630C8F}"/>
               </a:ext>
             </a:extLst>
           </p:cNvPr>
@@ -2633,7 +2633,7 @@
           <p:cNvPr id="3" name="Title">
             <a:extLst xmlns:a="http://schemas.openxmlformats.org/drawingml/2006/main">
               <a:ext uri="{FF2B5EF4-FFF2-40B4-BE49-F238E27FC236}">
-                <a16:creationId xmlns:a16="http://schemas.microsoft.com/office/drawing/2014/main" id="{38A94BAE-9A43-4791-B70F-80DF6019646C}"/>
+                <a16:creationId xmlns:a16="http://schemas.microsoft.com/office/drawing/2014/main" id="{E44F97B8-5604-4DA4-B61A-00E45A3A0C97}"/>
               </a:ext>
             </a:extLst>
           </p:cNvPr>
@@ -2790,7 +2790,7 @@
           <p:cNvPr id="2" name="Body">
             <a:extLst xmlns:a="http://schemas.openxmlformats.org/drawingml/2006/main">
               <a:ext uri="{FF2B5EF4-FFF2-40B4-BE49-F238E27FC236}">
-                <a16:creationId xmlns:a16="http://schemas.microsoft.com/office/drawing/2014/main" id="{7A96E83A-9C1E-4605-915E-585887092009}"/>
+                <a16:creationId xmlns:a16="http://schemas.microsoft.com/office/drawing/2014/main" id="{7CA1DA6F-A07E-4EB2-8B37-551645E50BEF}"/>
               </a:ext>
             </a:extLst>
           </p:cNvPr>
@@ -2964,7 +2964,7 @@
           <p:cNvPr id="4" name="Title">
             <a:extLst xmlns:a="http://schemas.openxmlformats.org/drawingml/2006/main">
               <a:ext uri="{FF2B5EF4-FFF2-40B4-BE49-F238E27FC236}">
-                <a16:creationId xmlns:a16="http://schemas.microsoft.com/office/drawing/2014/main" id="{006282C6-2009-4317-948A-AD54700CD510}"/>
+                <a16:creationId xmlns:a16="http://schemas.microsoft.com/office/drawing/2014/main" id="{2A3F5FF8-2EC3-487C-83D7-6EE626C3E26B}"/>
               </a:ext>
             </a:extLst>
           </p:cNvPr>
@@ -3121,7 +3121,7 @@
           <p:cNvPr id="2" name="Left column">
             <a:extLst xmlns:a="http://schemas.openxmlformats.org/drawingml/2006/main">
               <a:ext uri="{FF2B5EF4-FFF2-40B4-BE49-F238E27FC236}">
-                <a16:creationId xmlns:a16="http://schemas.microsoft.com/office/drawing/2014/main" id="{CA455443-62C9-49FD-8F17-4AF2807D52CE}"/>
+                <a16:creationId xmlns:a16="http://schemas.microsoft.com/office/drawing/2014/main" id="{0460899F-B3E7-4415-AE91-910E0B0EC2F1}"/>
               </a:ext>
             </a:extLst>
           </p:cNvPr>
@@ -3278,7 +3278,7 @@
           <p:cNvPr id="3" name="Right column">
             <a:extLst xmlns:a="http://schemas.openxmlformats.org/drawingml/2006/main">
               <a:ext uri="{FF2B5EF4-FFF2-40B4-BE49-F238E27FC236}">
-                <a16:creationId xmlns:a16="http://schemas.microsoft.com/office/drawing/2014/main" id="{CE398592-7A30-4A7E-8193-6518A2BFAA0B}"/>
+                <a16:creationId xmlns:a16="http://schemas.microsoft.com/office/drawing/2014/main" id="{340DEA16-3FED-4A4C-9967-7F62AACB3931}"/>
               </a:ext>
             </a:extLst>
           </p:cNvPr>
@@ -3452,7 +3452,7 @@
           <p:cNvPr id="3" name="Title">
             <a:extLst xmlns:a="http://schemas.openxmlformats.org/drawingml/2006/main">
               <a:ext uri="{FF2B5EF4-FFF2-40B4-BE49-F238E27FC236}">
-                <a16:creationId xmlns:a16="http://schemas.microsoft.com/office/drawing/2014/main" id="{0290172A-C465-44EE-8202-903D7B94E082}"/>
+                <a16:creationId xmlns:a16="http://schemas.microsoft.com/office/drawing/2014/main" id="{17406C65-9C3D-4295-8B6F-F84A5630654A}"/>
               </a:ext>
             </a:extLst>
           </p:cNvPr>
@@ -3609,7 +3609,7 @@
           <p:cNvPr id="2" name="Left column">
             <a:extLst xmlns:a="http://schemas.openxmlformats.org/drawingml/2006/main">
               <a:ext uri="{FF2B5EF4-FFF2-40B4-BE49-F238E27FC236}">
-                <a16:creationId xmlns:a16="http://schemas.microsoft.com/office/drawing/2014/main" id="{5A10D06E-401C-4402-8621-6AB344B4E430}"/>
+                <a16:creationId xmlns:a16="http://schemas.microsoft.com/office/drawing/2014/main" id="{A73D851A-0119-4F25-A361-2FF85AE9B7D5}"/>
               </a:ext>
             </a:extLst>
           </p:cNvPr>
@@ -3804,12 +3804,12 @@
   </p:cSld>
   <p:clrMap bg1="lt1" tx1="dk1" bg2="lt2" tx2="dk2" accent1="accent1" accent2="accent2" accent3="accent3" accent4="accent4" accent5="accent5" accent6="accent6" hlink="hlink" folHlink="folHlink"/>
   <p:sldLayoutIdLst>
-    <p:sldLayoutId xmlns:r="http://schemas.openxmlformats.org/officeDocument/2006/relationships" id="2147483649" r:id="R96e2de84da5f4265"/>
-    <p:sldLayoutId xmlns:r="http://schemas.openxmlformats.org/officeDocument/2006/relationships" id="2147483650" r:id="Rfe404aad3fd04773"/>
-    <p:sldLayoutId xmlns:r="http://schemas.openxmlformats.org/officeDocument/2006/relationships" id="2147483651" r:id="R645b35f25e774382"/>
-    <p:sldLayoutId xmlns:r="http://schemas.openxmlformats.org/officeDocument/2006/relationships" id="2147483652" r:id="Rdb0346c89f224e3c"/>
-    <p:sldLayoutId xmlns:r="http://schemas.openxmlformats.org/officeDocument/2006/relationships" id="2147483653" r:id="R5b689e13683d4cc2"/>
-    <p:sldLayoutId xmlns:r="http://schemas.openxmlformats.org/officeDocument/2006/relationships" id="2147483654" r:id="Rf9dd1f9403044954"/>
+    <p:sldLayoutId xmlns:r="http://schemas.openxmlformats.org/officeDocument/2006/relationships" id="2147483649" r:id="R739b60cd8a4e4280"/>
+    <p:sldLayoutId xmlns:r="http://schemas.openxmlformats.org/officeDocument/2006/relationships" id="2147483650" r:id="Ref6ea8f6473a47e6"/>
+    <p:sldLayoutId xmlns:r="http://schemas.openxmlformats.org/officeDocument/2006/relationships" id="2147483651" r:id="R0c2461779f704bfc"/>
+    <p:sldLayoutId xmlns:r="http://schemas.openxmlformats.org/officeDocument/2006/relationships" id="2147483652" r:id="R26d78940b98c4766"/>
+    <p:sldLayoutId xmlns:r="http://schemas.openxmlformats.org/officeDocument/2006/relationships" id="2147483653" r:id="R31e65d42249a49a8"/>
+    <p:sldLayoutId xmlns:r="http://schemas.openxmlformats.org/officeDocument/2006/relationships" id="2147483654" r:id="Rfc2febe5710243c7"/>
   </p:sldLayoutIdLst>
   <p:txStyles>
     <p:titleStyle>
@@ -5255,7 +5255,7 @@
           <p:cNvPr id="7" name="">
             <a:extLst xmlns:a="http://schemas.openxmlformats.org/drawingml/2006/main">
               <a:ext uri="{FF2B5EF4-FFF2-40B4-BE49-F238E27FC236}">
-                <a16:creationId xmlns:a16="http://schemas.microsoft.com/office/drawing/2014/main" id="{2E3E113D-87BC-4697-8661-36EFB30D8C23}"/>
+                <a16:creationId xmlns:a16="http://schemas.microsoft.com/office/drawing/2014/main" id="{701D3591-EEAC-4994-9AF9-424D46300A2E}"/>
               </a:ext>
             </a:extLst>
           </p:cNvPr>
@@ -5323,7 +5323,7 @@
           <p:cNvPr id="2" name="">
             <a:extLst xmlns:a="http://schemas.openxmlformats.org/drawingml/2006/main">
               <a:ext uri="{FF2B5EF4-FFF2-40B4-BE49-F238E27FC236}">
-                <a16:creationId xmlns:a16="http://schemas.microsoft.com/office/drawing/2014/main" id="{035051A3-9287-4B4D-95FC-8265056366EF}"/>
+                <a16:creationId xmlns:a16="http://schemas.microsoft.com/office/drawing/2014/main" id="{DDBF957E-5923-4CAB-ADD5-BBFA918CEA1E}"/>
               </a:ext>
             </a:extLst>
           </p:cNvPr>
@@ -5391,7 +5391,7 @@
           <p:cNvPr id="3" name="">
             <a:extLst xmlns:a="http://schemas.openxmlformats.org/drawingml/2006/main">
               <a:ext uri="{FF2B5EF4-FFF2-40B4-BE49-F238E27FC236}">
-                <a16:creationId xmlns:a16="http://schemas.microsoft.com/office/drawing/2014/main" id="{E301AE14-BCC9-4856-B271-9654870A3299}"/>
+                <a16:creationId xmlns:a16="http://schemas.microsoft.com/office/drawing/2014/main" id="{DF95E63F-2845-422C-98A5-CFE29941024A}"/>
               </a:ext>
             </a:extLst>
           </p:cNvPr>
@@ -5459,7 +5459,7 @@
           <p:cNvPr id="4" name="">
             <a:extLst xmlns:a="http://schemas.openxmlformats.org/drawingml/2006/main">
               <a:ext uri="{FF2B5EF4-FFF2-40B4-BE49-F238E27FC236}">
-                <a16:creationId xmlns:a16="http://schemas.microsoft.com/office/drawing/2014/main" id="{864236DC-35C1-4EF9-93D0-7429B01DB7E1}"/>
+                <a16:creationId xmlns:a16="http://schemas.microsoft.com/office/drawing/2014/main" id="{35D55988-75B1-415A-8CE6-B643C0A14954}"/>
               </a:ext>
             </a:extLst>
           </p:cNvPr>
@@ -5527,7 +5527,7 @@
           <p:cNvPr id="5" name="">
             <a:extLst xmlns:a="http://schemas.openxmlformats.org/drawingml/2006/main">
               <a:ext uri="{FF2B5EF4-FFF2-40B4-BE49-F238E27FC236}">
-                <a16:creationId xmlns:a16="http://schemas.microsoft.com/office/drawing/2014/main" id="{6DBD6225-DCBD-4898-8E48-2917EA44B6DA}"/>
+                <a16:creationId xmlns:a16="http://schemas.microsoft.com/office/drawing/2014/main" id="{AA1B9AF0-8114-4C82-948D-971562959C9D}"/>
               </a:ext>
             </a:extLst>
           </p:cNvPr>
@@ -5595,7 +5595,7 @@
           <p:cNvPr id="6" name="">
             <a:extLst xmlns:a="http://schemas.openxmlformats.org/drawingml/2006/main">
               <a:ext uri="{FF2B5EF4-FFF2-40B4-BE49-F238E27FC236}">
-                <a16:creationId xmlns:a16="http://schemas.microsoft.com/office/drawing/2014/main" id="{AB0E0FBF-B523-4648-88E6-FCF53179500D}"/>
+                <a16:creationId xmlns:a16="http://schemas.microsoft.com/office/drawing/2014/main" id="{74249871-20F0-4FCC-84A4-C781FB24D0DB}"/>
               </a:ext>
             </a:extLst>
           </p:cNvPr>
@@ -5684,7 +5684,7 @@
     </p:spTree>
     <p:extLst>
       <p:ext uri="{BB962C8B-B14F-4D97-AF65-F5344CB8AC3E}">
-        <p14:creationId xmlns:p14="http://schemas.microsoft.com/office/powerpoint/2010/main" val="548694554"/>
+        <p14:creationId xmlns:p14="http://schemas.microsoft.com/office/powerpoint/2010/main" val="1640644892"/>
       </p:ext>
     </p:extLst>
   </p:cSld>
@@ -5715,7 +5715,7 @@
           <p:cNvPr id="8" name="">
             <a:extLst xmlns:a="http://schemas.openxmlformats.org/drawingml/2006/main">
               <a:ext uri="{FF2B5EF4-FFF2-40B4-BE49-F238E27FC236}">
-                <a16:creationId xmlns:a16="http://schemas.microsoft.com/office/drawing/2014/main" id="{D3AD7D4A-9EF8-4987-B903-EF17CF6265D4}"/>
+                <a16:creationId xmlns:a16="http://schemas.microsoft.com/office/drawing/2014/main" id="{C615F2B0-67BD-4EB9-8559-D0B7F5618E79}"/>
               </a:ext>
             </a:extLst>
           </p:cNvPr>
@@ -5783,7 +5783,7 @@
           <p:cNvPr id="2" name="">
             <a:extLst xmlns:a="http://schemas.openxmlformats.org/drawingml/2006/main">
               <a:ext uri="{FF2B5EF4-FFF2-40B4-BE49-F238E27FC236}">
-                <a16:creationId xmlns:a16="http://schemas.microsoft.com/office/drawing/2014/main" id="{2DEB47E6-F113-47A3-A44F-E6B6E7FFF17E}"/>
+                <a16:creationId xmlns:a16="http://schemas.microsoft.com/office/drawing/2014/main" id="{52168526-1505-4BA7-B8D4-135245269755}"/>
               </a:ext>
             </a:extLst>
           </p:cNvPr>
@@ -5851,7 +5851,7 @@
           <p:cNvPr id="3" name="">
             <a:extLst xmlns:a="http://schemas.openxmlformats.org/drawingml/2006/main">
               <a:ext uri="{FF2B5EF4-FFF2-40B4-BE49-F238E27FC236}">
-                <a16:creationId xmlns:a16="http://schemas.microsoft.com/office/drawing/2014/main" id="{396594AB-7062-4789-9CE1-C67A5E136D27}"/>
+                <a16:creationId xmlns:a16="http://schemas.microsoft.com/office/drawing/2014/main" id="{3A602BEF-DFE6-47AB-8C34-9F121D523086}"/>
               </a:ext>
             </a:extLst>
           </p:cNvPr>
@@ -5919,7 +5919,7 @@
           <p:cNvPr id="4" name="Chart">
             <a:extLst xmlns:a="http://schemas.openxmlformats.org/drawingml/2006/main">
               <a:ext uri="{FF2B5EF4-FFF2-40B4-BE49-F238E27FC236}">
-                <a16:creationId xmlns:a16="http://schemas.microsoft.com/office/drawing/2014/main" id="{449EC396-A574-45F8-88FF-29C13C3FAA14}"/>
+                <a16:creationId xmlns:a16="http://schemas.microsoft.com/office/drawing/2014/main" id="{06F0E50A-F81A-4B10-96E2-CB6B57D0BFBB}"/>
               </a:ext>
             </a:extLst>
           </p:cNvPr>
@@ -5932,7 +5932,7 @@
         </p:xfrm>
         <a:graphic xmlns:a="http://schemas.openxmlformats.org/drawingml/2006/main">
           <a:graphicData uri="http://schemas.openxmlformats.org/drawingml/2006/chart">
-            <c:chart xmlns:r="http://schemas.openxmlformats.org/officeDocument/2006/relationships" xmlns:c="http://schemas.openxmlformats.org/drawingml/2006/chart" r:id="Rc8e42c810b704356"/>
+            <c:chart xmlns:r="http://schemas.openxmlformats.org/officeDocument/2006/relationships" xmlns:c="http://schemas.openxmlformats.org/drawingml/2006/chart" r:id="R286e7ce55e544398"/>
           </a:graphicData>
         </a:graphic>
       </p:graphicFrame>
@@ -5941,7 +5941,7 @@
           <p:cNvPr id="5" name="">
             <a:extLst xmlns:a="http://schemas.openxmlformats.org/drawingml/2006/main">
               <a:ext uri="{FF2B5EF4-FFF2-40B4-BE49-F238E27FC236}">
-                <a16:creationId xmlns:a16="http://schemas.microsoft.com/office/drawing/2014/main" id="{653A3813-FD4E-49D7-99E4-47C63683AF65}"/>
+                <a16:creationId xmlns:a16="http://schemas.microsoft.com/office/drawing/2014/main" id="{0B26FFEC-3793-4154-B4A9-595B8C6290EB}"/>
               </a:ext>
             </a:extLst>
           </p:cNvPr>
@@ -6032,7 +6032,7 @@
           <p:cNvPr id="6" name="">
             <a:extLst xmlns:a="http://schemas.openxmlformats.org/drawingml/2006/main">
               <a:ext uri="{FF2B5EF4-FFF2-40B4-BE49-F238E27FC236}">
-                <a16:creationId xmlns:a16="http://schemas.microsoft.com/office/drawing/2014/main" id="{98BE552F-4D20-424D-8BC9-B7109FC37AD2}"/>
+                <a16:creationId xmlns:a16="http://schemas.microsoft.com/office/drawing/2014/main" id="{A50DB512-F9BC-49BB-8437-A988573C4B1B}"/>
               </a:ext>
             </a:extLst>
           </p:cNvPr>
@@ -6123,7 +6123,7 @@
           <p:cNvPr id="7" name="">
             <a:extLst xmlns:a="http://schemas.openxmlformats.org/drawingml/2006/main">
               <a:ext uri="{FF2B5EF4-FFF2-40B4-BE49-F238E27FC236}">
-                <a16:creationId xmlns:a16="http://schemas.microsoft.com/office/drawing/2014/main" id="{C48CC5D0-1C78-4EE2-B745-60EC10EC31B3}"/>
+                <a16:creationId xmlns:a16="http://schemas.microsoft.com/office/drawing/2014/main" id="{B1B87049-CA88-48B1-A6FD-53939AB47322}"/>
               </a:ext>
             </a:extLst>
           </p:cNvPr>
@@ -6189,7 +6189,7 @@
     </p:spTree>
     <p:extLst>
       <p:ext uri="{BB962C8B-B14F-4D97-AF65-F5344CB8AC3E}">
-        <p14:creationId xmlns:p14="http://schemas.microsoft.com/office/powerpoint/2010/main" val="733688347"/>
+        <p14:creationId xmlns:p14="http://schemas.microsoft.com/office/powerpoint/2010/main" val="1545396701"/>
       </p:ext>
     </p:extLst>
   </p:cSld>
@@ -6220,7 +6220,7 @@
           <p:cNvPr id="6" name="">
             <a:extLst xmlns:a="http://schemas.openxmlformats.org/drawingml/2006/main">
               <a:ext uri="{FF2B5EF4-FFF2-40B4-BE49-F238E27FC236}">
-                <a16:creationId xmlns:a16="http://schemas.microsoft.com/office/drawing/2014/main" id="{C884A3E1-F045-4389-8FFF-76FEBF4BB221}"/>
+                <a16:creationId xmlns:a16="http://schemas.microsoft.com/office/drawing/2014/main" id="{A07A7A2A-BF5A-4B0C-B345-190026D9E80F}"/>
               </a:ext>
             </a:extLst>
           </p:cNvPr>
@@ -6288,7 +6288,7 @@
           <p:cNvPr id="2" name="">
             <a:extLst xmlns:a="http://schemas.openxmlformats.org/drawingml/2006/main">
               <a:ext uri="{FF2B5EF4-FFF2-40B4-BE49-F238E27FC236}">
-                <a16:creationId xmlns:a16="http://schemas.microsoft.com/office/drawing/2014/main" id="{3B167099-E4E1-48AC-BE03-65A14307277C}"/>
+                <a16:creationId xmlns:a16="http://schemas.microsoft.com/office/drawing/2014/main" id="{0B70967A-0E8D-4A68-990E-BCC7224ED30A}"/>
               </a:ext>
             </a:extLst>
           </p:cNvPr>
@@ -6356,7 +6356,7 @@
           <p:cNvPr id="3" name="">
             <a:extLst xmlns:a="http://schemas.openxmlformats.org/drawingml/2006/main">
               <a:ext uri="{FF2B5EF4-FFF2-40B4-BE49-F238E27FC236}">
-                <a16:creationId xmlns:a16="http://schemas.microsoft.com/office/drawing/2014/main" id="{143847D1-6E16-47CA-8399-B9739858A8C7}"/>
+                <a16:creationId xmlns:a16="http://schemas.microsoft.com/office/drawing/2014/main" id="{52340D14-13D3-4FFA-BEA0-7E2511C5458D}"/>
               </a:ext>
             </a:extLst>
           </p:cNvPr>
@@ -6424,7 +6424,7 @@
           <p:cNvPr id="4" name="Chart">
             <a:extLst xmlns:a="http://schemas.openxmlformats.org/drawingml/2006/main">
               <a:ext uri="{FF2B5EF4-FFF2-40B4-BE49-F238E27FC236}">
-                <a16:creationId xmlns:a16="http://schemas.microsoft.com/office/drawing/2014/main" id="{767E8A1F-F11C-427A-86FF-53C40DA3473F}"/>
+                <a16:creationId xmlns:a16="http://schemas.microsoft.com/office/drawing/2014/main" id="{379C7493-3AC3-46AB-9A59-BE90FFA429C4}"/>
               </a:ext>
             </a:extLst>
           </p:cNvPr>
@@ -6437,7 +6437,7 @@
         </p:xfrm>
         <a:graphic xmlns:a="http://schemas.openxmlformats.org/drawingml/2006/main">
           <a:graphicData uri="http://schemas.openxmlformats.org/drawingml/2006/chart">
-            <c:chart xmlns:r="http://schemas.openxmlformats.org/officeDocument/2006/relationships" xmlns:c="http://schemas.openxmlformats.org/drawingml/2006/chart" r:id="R60358e9d02f54cb2"/>
+            <c:chart xmlns:r="http://schemas.openxmlformats.org/officeDocument/2006/relationships" xmlns:c="http://schemas.openxmlformats.org/drawingml/2006/chart" r:id="R6d7bd3a422734644"/>
           </a:graphicData>
         </a:graphic>
       </p:graphicFrame>
@@ -6446,7 +6446,7 @@
           <p:cNvPr id="5" name="">
             <a:extLst xmlns:a="http://schemas.openxmlformats.org/drawingml/2006/main">
               <a:ext uri="{FF2B5EF4-FFF2-40B4-BE49-F238E27FC236}">
-                <a16:creationId xmlns:a16="http://schemas.microsoft.com/office/drawing/2014/main" id="{99262982-12CE-47F7-845D-56189DEBF630}"/>
+                <a16:creationId xmlns:a16="http://schemas.microsoft.com/office/drawing/2014/main" id="{0C390DC5-D574-4A64-8A02-CC21EC1D4BD6}"/>
               </a:ext>
             </a:extLst>
           </p:cNvPr>
@@ -6512,7 +6512,7 @@
     </p:spTree>
     <p:extLst>
       <p:ext uri="{BB962C8B-B14F-4D97-AF65-F5344CB8AC3E}">
-        <p14:creationId xmlns:p14="http://schemas.microsoft.com/office/powerpoint/2010/main" val="2076237082"/>
+        <p14:creationId xmlns:p14="http://schemas.microsoft.com/office/powerpoint/2010/main" val="611523856"/>
       </p:ext>
     </p:extLst>
   </p:cSld>
@@ -6543,7 +6543,7 @@
           <p:cNvPr id="6" name="">
             <a:extLst xmlns:a="http://schemas.openxmlformats.org/drawingml/2006/main">
               <a:ext uri="{FF2B5EF4-FFF2-40B4-BE49-F238E27FC236}">
-                <a16:creationId xmlns:a16="http://schemas.microsoft.com/office/drawing/2014/main" id="{17F094BA-3274-4CED-A518-A36BFC1ED9C6}"/>
+                <a16:creationId xmlns:a16="http://schemas.microsoft.com/office/drawing/2014/main" id="{996818D7-C103-4A42-B33A-58CDD9CC3C6C}"/>
               </a:ext>
             </a:extLst>
           </p:cNvPr>
@@ -6611,7 +6611,7 @@
           <p:cNvPr id="2" name="">
             <a:extLst xmlns:a="http://schemas.openxmlformats.org/drawingml/2006/main">
               <a:ext uri="{FF2B5EF4-FFF2-40B4-BE49-F238E27FC236}">
-                <a16:creationId xmlns:a16="http://schemas.microsoft.com/office/drawing/2014/main" id="{E4247BC7-B329-4026-9E9C-33DCD8F68190}"/>
+                <a16:creationId xmlns:a16="http://schemas.microsoft.com/office/drawing/2014/main" id="{8FCEE29B-F5C7-4B5C-8E41-3C97EDBC63F8}"/>
               </a:ext>
             </a:extLst>
           </p:cNvPr>
@@ -6679,7 +6679,7 @@
           <p:cNvPr id="3" name="">
             <a:extLst xmlns:a="http://schemas.openxmlformats.org/drawingml/2006/main">
               <a:ext uri="{FF2B5EF4-FFF2-40B4-BE49-F238E27FC236}">
-                <a16:creationId xmlns:a16="http://schemas.microsoft.com/office/drawing/2014/main" id="{26F61A21-5EF3-44F4-BE61-BEAEB84966A4}"/>
+                <a16:creationId xmlns:a16="http://schemas.microsoft.com/office/drawing/2014/main" id="{F2D4B81F-0D85-4158-94C8-279A3AAC8F78}"/>
               </a:ext>
             </a:extLst>
           </p:cNvPr>
@@ -6747,7 +6747,7 @@
           <p:cNvPr id="4" name="">
             <a:extLst xmlns:a="http://schemas.openxmlformats.org/drawingml/2006/main">
               <a:ext uri="{FF2B5EF4-FFF2-40B4-BE49-F238E27FC236}">
-                <a16:creationId xmlns:a16="http://schemas.microsoft.com/office/drawing/2014/main" id="{2D0C2248-F1BB-4119-B201-4B1F05522EAF}"/>
+                <a16:creationId xmlns:a16="http://schemas.microsoft.com/office/drawing/2014/main" id="{5F728245-06C9-4CC9-AC1E-7DC39DC9DC8F}"/>
               </a:ext>
             </a:extLst>
           </p:cNvPr>
@@ -6757,7 +6757,7 @@
           <p:nvPr/>
         </p:nvPicPr>
         <p:blipFill>
-          <a:blip xmlns:r="http://schemas.openxmlformats.org/officeDocument/2006/relationships" xmlns:a="http://schemas.openxmlformats.org/drawingml/2006/main" r:embed="Rc6388776d6424d93"/>
+          <a:blip xmlns:r="http://schemas.openxmlformats.org/officeDocument/2006/relationships" xmlns:a="http://schemas.openxmlformats.org/drawingml/2006/main" r:embed="R6cfa051902094e75"/>
           <a:stretch xmlns:a="http://schemas.openxmlformats.org/drawingml/2006/main"/>
         </p:blipFill>
         <p:spPr>
@@ -6775,7 +6775,7 @@
           <p:cNvPr id="5" name="">
             <a:extLst xmlns:a="http://schemas.openxmlformats.org/drawingml/2006/main">
               <a:ext uri="{FF2B5EF4-FFF2-40B4-BE49-F238E27FC236}">
-                <a16:creationId xmlns:a16="http://schemas.microsoft.com/office/drawing/2014/main" id="{7A0BD54B-4055-4999-8DE6-7193F2F023A2}"/>
+                <a16:creationId xmlns:a16="http://schemas.microsoft.com/office/drawing/2014/main" id="{7A507DAB-F849-4F18-ABF8-FF4E05D65B0E}"/>
               </a:ext>
             </a:extLst>
           </p:cNvPr>
@@ -6841,7 +6841,7 @@
     </p:spTree>
     <p:extLst>
       <p:ext uri="{BB962C8B-B14F-4D97-AF65-F5344CB8AC3E}">
-        <p14:creationId xmlns:p14="http://schemas.microsoft.com/office/powerpoint/2010/main" val="1877167230"/>
+        <p14:creationId xmlns:p14="http://schemas.microsoft.com/office/powerpoint/2010/main" val="2104722697"/>
       </p:ext>
     </p:extLst>
   </p:cSld>
@@ -6872,7 +6872,7 @@
           <p:cNvPr id="5" name="">
             <a:extLst xmlns:a="http://schemas.openxmlformats.org/drawingml/2006/main">
               <a:ext uri="{FF2B5EF4-FFF2-40B4-BE49-F238E27FC236}">
-                <a16:creationId xmlns:a16="http://schemas.microsoft.com/office/drawing/2014/main" id="{704F794C-6F96-4703-9C73-D5D4ABDA6D43}"/>
+                <a16:creationId xmlns:a16="http://schemas.microsoft.com/office/drawing/2014/main" id="{B6EEF6F8-4B0E-4CC2-93D6-100ECF935515}"/>
               </a:ext>
             </a:extLst>
           </p:cNvPr>
@@ -6940,7 +6940,7 @@
           <p:cNvPr id="2" name="">
             <a:extLst xmlns:a="http://schemas.openxmlformats.org/drawingml/2006/main">
               <a:ext uri="{FF2B5EF4-FFF2-40B4-BE49-F238E27FC236}">
-                <a16:creationId xmlns:a16="http://schemas.microsoft.com/office/drawing/2014/main" id="{4D9336DC-2FC3-4A10-BC84-DBDC0CDF4DFD}"/>
+                <a16:creationId xmlns:a16="http://schemas.microsoft.com/office/drawing/2014/main" id="{B6B41734-716A-4430-911E-6B7C61671BE0}"/>
               </a:ext>
             </a:extLst>
           </p:cNvPr>
@@ -7008,7 +7008,7 @@
           <p:cNvPr id="3" name="">
             <a:extLst xmlns:a="http://schemas.openxmlformats.org/drawingml/2006/main">
               <a:ext uri="{FF2B5EF4-FFF2-40B4-BE49-F238E27FC236}">
-                <a16:creationId xmlns:a16="http://schemas.microsoft.com/office/drawing/2014/main" id="{648FADB8-0C4B-485A-8573-635723F8201A}"/>
+                <a16:creationId xmlns:a16="http://schemas.microsoft.com/office/drawing/2014/main" id="{0074E75D-0AC8-4334-A87E-F6053855876F}"/>
               </a:ext>
             </a:extLst>
           </p:cNvPr>
@@ -7076,7 +7076,7 @@
           <p:cNvPr id="4" name="">
             <a:extLst xmlns:a="http://schemas.openxmlformats.org/drawingml/2006/main">
               <a:ext uri="{FF2B5EF4-FFF2-40B4-BE49-F238E27FC236}">
-                <a16:creationId xmlns:a16="http://schemas.microsoft.com/office/drawing/2014/main" id="{EDF27975-0441-4D95-8E91-2D0C5D9D1C96}"/>
+                <a16:creationId xmlns:a16="http://schemas.microsoft.com/office/drawing/2014/main" id="{43BE7297-23E1-4BF1-B632-DFEDC17CEA78}"/>
               </a:ext>
             </a:extLst>
           </p:cNvPr>
@@ -7701,7 +7701,7 @@
     </p:spTree>
     <p:extLst>
       <p:ext uri="{BB962C8B-B14F-4D97-AF65-F5344CB8AC3E}">
-        <p14:creationId xmlns:p14="http://schemas.microsoft.com/office/powerpoint/2010/main" val="378239237"/>
+        <p14:creationId xmlns:p14="http://schemas.microsoft.com/office/powerpoint/2010/main" val="1844366953"/>
       </p:ext>
     </p:extLst>
   </p:cSld>
@@ -7732,7 +7732,7 @@
           <p:cNvPr id="8" name="">
             <a:extLst xmlns:a="http://schemas.openxmlformats.org/drawingml/2006/main">
               <a:ext uri="{FF2B5EF4-FFF2-40B4-BE49-F238E27FC236}">
-                <a16:creationId xmlns:a16="http://schemas.microsoft.com/office/drawing/2014/main" id="{483D53A9-DD1E-4A8B-A812-CEB35A0B5986}"/>
+                <a16:creationId xmlns:a16="http://schemas.microsoft.com/office/drawing/2014/main" id="{6A9E006F-28D0-496D-A766-99F2592911D5}"/>
               </a:ext>
             </a:extLst>
           </p:cNvPr>
@@ -7800,7 +7800,7 @@
           <p:cNvPr id="2" name="">
             <a:extLst xmlns:a="http://schemas.openxmlformats.org/drawingml/2006/main">
               <a:ext uri="{FF2B5EF4-FFF2-40B4-BE49-F238E27FC236}">
-                <a16:creationId xmlns:a16="http://schemas.microsoft.com/office/drawing/2014/main" id="{FF588119-C2D4-485D-84AE-44B66EFB4C0B}"/>
+                <a16:creationId xmlns:a16="http://schemas.microsoft.com/office/drawing/2014/main" id="{8960F6B9-A003-4CD2-8A5E-5C8852B11CD9}"/>
               </a:ext>
             </a:extLst>
           </p:cNvPr>
@@ -7868,7 +7868,7 @@
           <p:cNvPr id="3" name="">
             <a:extLst xmlns:a="http://schemas.openxmlformats.org/drawingml/2006/main">
               <a:ext uri="{FF2B5EF4-FFF2-40B4-BE49-F238E27FC236}">
-                <a16:creationId xmlns:a16="http://schemas.microsoft.com/office/drawing/2014/main" id="{AB986F75-AA28-4E77-8D39-56AF7C62B259}"/>
+                <a16:creationId xmlns:a16="http://schemas.microsoft.com/office/drawing/2014/main" id="{8E805D43-60A1-4606-98F4-5FED962D35F9}"/>
               </a:ext>
             </a:extLst>
           </p:cNvPr>
@@ -7936,7 +7936,7 @@
           <p:cNvPr id="4" name="">
             <a:extLst xmlns:a="http://schemas.openxmlformats.org/drawingml/2006/main">
               <a:ext uri="{FF2B5EF4-FFF2-40B4-BE49-F238E27FC236}">
-                <a16:creationId xmlns:a16="http://schemas.microsoft.com/office/drawing/2014/main" id="{84AD2AEB-DB73-4346-86E3-047178C61089}"/>
+                <a16:creationId xmlns:a16="http://schemas.microsoft.com/office/drawing/2014/main" id="{F5B05BEA-50F4-4D9C-BA9E-87504170D8C3}"/>
               </a:ext>
             </a:extLst>
           </p:cNvPr>
@@ -8004,7 +8004,7 @@
           <p:cNvPr id="5" name="">
             <a:extLst xmlns:a="http://schemas.openxmlformats.org/drawingml/2006/main">
               <a:ext uri="{FF2B5EF4-FFF2-40B4-BE49-F238E27FC236}">
-                <a16:creationId xmlns:a16="http://schemas.microsoft.com/office/drawing/2014/main" id="{59778D86-DFD7-4C81-9BAE-BC74E094D383}"/>
+                <a16:creationId xmlns:a16="http://schemas.microsoft.com/office/drawing/2014/main" id="{4BCF6591-ABBD-4BCD-969A-403D1500D9E1}"/>
               </a:ext>
             </a:extLst>
           </p:cNvPr>
@@ -8072,7 +8072,7 @@
           <p:cNvPr id="6" name="">
             <a:extLst xmlns:a="http://schemas.openxmlformats.org/drawingml/2006/main">
               <a:ext uri="{FF2B5EF4-FFF2-40B4-BE49-F238E27FC236}">
-                <a16:creationId xmlns:a16="http://schemas.microsoft.com/office/drawing/2014/main" id="{E7FE7B93-CF6A-488F-9DB5-5EEC5072478E}"/>
+                <a16:creationId xmlns:a16="http://schemas.microsoft.com/office/drawing/2014/main" id="{4F34E41D-5FA6-4D61-8A60-C877CEF0E8F2}"/>
               </a:ext>
             </a:extLst>
           </p:cNvPr>
@@ -8140,7 +8140,7 @@
           <p:cNvPr id="7" name="">
             <a:extLst xmlns:a="http://schemas.openxmlformats.org/drawingml/2006/main">
               <a:ext uri="{FF2B5EF4-FFF2-40B4-BE49-F238E27FC236}">
-                <a16:creationId xmlns:a16="http://schemas.microsoft.com/office/drawing/2014/main" id="{B6F0194F-9B07-4659-8FEF-58352C545AA3}"/>
+                <a16:creationId xmlns:a16="http://schemas.microsoft.com/office/drawing/2014/main" id="{29220754-DD5F-4B76-8224-1A8B9C66E58D}"/>
               </a:ext>
             </a:extLst>
           </p:cNvPr>
@@ -8206,7 +8206,7 @@
     </p:spTree>
     <p:extLst>
       <p:ext uri="{BB962C8B-B14F-4D97-AF65-F5344CB8AC3E}">
-        <p14:creationId xmlns:p14="http://schemas.microsoft.com/office/powerpoint/2010/main" val="1878220076"/>
+        <p14:creationId xmlns:p14="http://schemas.microsoft.com/office/powerpoint/2010/main" val="566519906"/>
       </p:ext>
     </p:extLst>
   </p:cSld>
@@ -8237,7 +8237,7 @@
           <p:cNvPr id="5" name="">
             <a:extLst xmlns:a="http://schemas.openxmlformats.org/drawingml/2006/main">
               <a:ext uri="{FF2B5EF4-FFF2-40B4-BE49-F238E27FC236}">
-                <a16:creationId xmlns:a16="http://schemas.microsoft.com/office/drawing/2014/main" id="{95D7C108-133A-49DC-84FE-AB1E38D7C2ED}"/>
+                <a16:creationId xmlns:a16="http://schemas.microsoft.com/office/drawing/2014/main" id="{63D7F398-4EC2-47DD-9E89-5B69BF58C08C}"/>
               </a:ext>
             </a:extLst>
           </p:cNvPr>
@@ -8305,7 +8305,7 @@
           <p:cNvPr id="2" name="">
             <a:extLst xmlns:a="http://schemas.openxmlformats.org/drawingml/2006/main">
               <a:ext uri="{FF2B5EF4-FFF2-40B4-BE49-F238E27FC236}">
-                <a16:creationId xmlns:a16="http://schemas.microsoft.com/office/drawing/2014/main" id="{D696B418-FAD6-460D-A14C-7F207A843294}"/>
+                <a16:creationId xmlns:a16="http://schemas.microsoft.com/office/drawing/2014/main" id="{DC931BDD-253C-4A79-B88E-B282F1F77370}"/>
               </a:ext>
             </a:extLst>
           </p:cNvPr>
@@ -8373,7 +8373,7 @@
           <p:cNvPr id="3" name="">
             <a:extLst xmlns:a="http://schemas.openxmlformats.org/drawingml/2006/main">
               <a:ext uri="{FF2B5EF4-FFF2-40B4-BE49-F238E27FC236}">
-                <a16:creationId xmlns:a16="http://schemas.microsoft.com/office/drawing/2014/main" id="{08C7F38D-5D72-4634-9781-24F2C4E9027B}"/>
+                <a16:creationId xmlns:a16="http://schemas.microsoft.com/office/drawing/2014/main" id="{C035443D-8415-4B5E-829C-7C58D9729D6C}"/>
               </a:ext>
             </a:extLst>
           </p:cNvPr>
@@ -8441,7 +8441,7 @@
           <p:cNvPr id="4" name="">
             <a:extLst xmlns:a="http://schemas.openxmlformats.org/drawingml/2006/main">
               <a:ext uri="{FF2B5EF4-FFF2-40B4-BE49-F238E27FC236}">
-                <a16:creationId xmlns:a16="http://schemas.microsoft.com/office/drawing/2014/main" id="{A157A42E-3668-429B-A01D-944C4918B40F}"/>
+                <a16:creationId xmlns:a16="http://schemas.microsoft.com/office/drawing/2014/main" id="{5D0E6BF6-8994-4E3E-81A8-4B65A88A4C2D}"/>
               </a:ext>
             </a:extLst>
           </p:cNvPr>
@@ -9066,7 +9066,7 @@
     </p:spTree>
     <p:extLst>
       <p:ext uri="{BB962C8B-B14F-4D97-AF65-F5344CB8AC3E}">
-        <p14:creationId xmlns:p14="http://schemas.microsoft.com/office/powerpoint/2010/main" val="1480525377"/>
+        <p14:creationId xmlns:p14="http://schemas.microsoft.com/office/powerpoint/2010/main" val="1449810227"/>
       </p:ext>
     </p:extLst>
   </p:cSld>
@@ -9097,7 +9097,7 @@
           <p:cNvPr id="8" name="">
             <a:extLst xmlns:a="http://schemas.openxmlformats.org/drawingml/2006/main">
               <a:ext uri="{FF2B5EF4-FFF2-40B4-BE49-F238E27FC236}">
-                <a16:creationId xmlns:a16="http://schemas.microsoft.com/office/drawing/2014/main" id="{C33AF004-C516-441F-BE27-EB6BE8989A60}"/>
+                <a16:creationId xmlns:a16="http://schemas.microsoft.com/office/drawing/2014/main" id="{B22A19C2-7BB6-4E3A-AFBB-601BE0CC787B}"/>
               </a:ext>
             </a:extLst>
           </p:cNvPr>
@@ -9165,7 +9165,7 @@
           <p:cNvPr id="2" name="">
             <a:extLst xmlns:a="http://schemas.openxmlformats.org/drawingml/2006/main">
               <a:ext uri="{FF2B5EF4-FFF2-40B4-BE49-F238E27FC236}">
-                <a16:creationId xmlns:a16="http://schemas.microsoft.com/office/drawing/2014/main" id="{3E87243D-4643-497B-8FC0-425943C1C1BE}"/>
+                <a16:creationId xmlns:a16="http://schemas.microsoft.com/office/drawing/2014/main" id="{2F07EE28-3E85-460F-9F71-829FC9064F48}"/>
               </a:ext>
             </a:extLst>
           </p:cNvPr>
@@ -9233,7 +9233,7 @@
           <p:cNvPr id="3" name="">
             <a:extLst xmlns:a="http://schemas.openxmlformats.org/drawingml/2006/main">
               <a:ext uri="{FF2B5EF4-FFF2-40B4-BE49-F238E27FC236}">
-                <a16:creationId xmlns:a16="http://schemas.microsoft.com/office/drawing/2014/main" id="{DFE2DE6D-2B88-4BEF-8301-71FEDC3030A8}"/>
+                <a16:creationId xmlns:a16="http://schemas.microsoft.com/office/drawing/2014/main" id="{C63867F8-E666-4679-9A67-8850F15AA88A}"/>
               </a:ext>
             </a:extLst>
           </p:cNvPr>
@@ -9301,7 +9301,7 @@
           <p:cNvPr id="4" name="">
             <a:extLst xmlns:a="http://schemas.openxmlformats.org/drawingml/2006/main">
               <a:ext uri="{FF2B5EF4-FFF2-40B4-BE49-F238E27FC236}">
-                <a16:creationId xmlns:a16="http://schemas.microsoft.com/office/drawing/2014/main" id="{52C066F0-0C39-49AC-B167-3632B946DD56}"/>
+                <a16:creationId xmlns:a16="http://schemas.microsoft.com/office/drawing/2014/main" id="{CAF96F95-D937-4113-BA5E-888DB2651232}"/>
               </a:ext>
             </a:extLst>
           </p:cNvPr>
@@ -9369,7 +9369,7 @@
           <p:cNvPr id="5" name="">
             <a:extLst xmlns:a="http://schemas.openxmlformats.org/drawingml/2006/main">
               <a:ext uri="{FF2B5EF4-FFF2-40B4-BE49-F238E27FC236}">
-                <a16:creationId xmlns:a16="http://schemas.microsoft.com/office/drawing/2014/main" id="{94C393C8-4C73-4D25-BA83-C5E57120BE2C}"/>
+                <a16:creationId xmlns:a16="http://schemas.microsoft.com/office/drawing/2014/main" id="{28C0E5B1-F4F1-4DE0-BCF6-9FA6977F578E}"/>
               </a:ext>
             </a:extLst>
           </p:cNvPr>
@@ -9437,7 +9437,7 @@
           <p:cNvPr id="6" name="">
             <a:extLst xmlns:a="http://schemas.openxmlformats.org/drawingml/2006/main">
               <a:ext uri="{FF2B5EF4-FFF2-40B4-BE49-F238E27FC236}">
-                <a16:creationId xmlns:a16="http://schemas.microsoft.com/office/drawing/2014/main" id="{D645E9D2-F6B9-4CF4-9823-037CE63DD1E8}"/>
+                <a16:creationId xmlns:a16="http://schemas.microsoft.com/office/drawing/2014/main" id="{2401DEE4-7608-4EAD-90CC-030B19CA050E}"/>
               </a:ext>
             </a:extLst>
           </p:cNvPr>
@@ -9505,7 +9505,7 @@
           <p:cNvPr id="7" name="">
             <a:extLst xmlns:a="http://schemas.openxmlformats.org/drawingml/2006/main">
               <a:ext uri="{FF2B5EF4-FFF2-40B4-BE49-F238E27FC236}">
-                <a16:creationId xmlns:a16="http://schemas.microsoft.com/office/drawing/2014/main" id="{0CA05269-DDD1-46B9-9B74-976546C508BB}"/>
+                <a16:creationId xmlns:a16="http://schemas.microsoft.com/office/drawing/2014/main" id="{E8124C35-4E1A-407D-9019-A3A60D7D4F2A}"/>
               </a:ext>
             </a:extLst>
           </p:cNvPr>
@@ -9571,7 +9571,7 @@
     </p:spTree>
     <p:extLst>
       <p:ext uri="{BB962C8B-B14F-4D97-AF65-F5344CB8AC3E}">
-        <p14:creationId xmlns:p14="http://schemas.microsoft.com/office/powerpoint/2010/main" val="10650140"/>
+        <p14:creationId xmlns:p14="http://schemas.microsoft.com/office/powerpoint/2010/main" val="173847746"/>
       </p:ext>
     </p:extLst>
   </p:cSld>
@@ -9602,7 +9602,7 @@
           <p:cNvPr id="8" name="">
             <a:extLst xmlns:a="http://schemas.openxmlformats.org/drawingml/2006/main">
               <a:ext uri="{FF2B5EF4-FFF2-40B4-BE49-F238E27FC236}">
-                <a16:creationId xmlns:a16="http://schemas.microsoft.com/office/drawing/2014/main" id="{0612205D-9153-468B-B15A-2F471D5BC5F5}"/>
+                <a16:creationId xmlns:a16="http://schemas.microsoft.com/office/drawing/2014/main" id="{58B2CD14-4220-49A8-9698-E33A6D7A755A}"/>
               </a:ext>
             </a:extLst>
           </p:cNvPr>
@@ -9670,7 +9670,7 @@
           <p:cNvPr id="2" name="">
             <a:extLst xmlns:a="http://schemas.openxmlformats.org/drawingml/2006/main">
               <a:ext uri="{FF2B5EF4-FFF2-40B4-BE49-F238E27FC236}">
-                <a16:creationId xmlns:a16="http://schemas.microsoft.com/office/drawing/2014/main" id="{DF183204-121F-4DC3-9972-E6667D6509EF}"/>
+                <a16:creationId xmlns:a16="http://schemas.microsoft.com/office/drawing/2014/main" id="{97172089-AE3F-41F2-BC0A-D611582CBB47}"/>
               </a:ext>
             </a:extLst>
           </p:cNvPr>
@@ -9738,7 +9738,7 @@
           <p:cNvPr id="3" name="">
             <a:extLst xmlns:a="http://schemas.openxmlformats.org/drawingml/2006/main">
               <a:ext uri="{FF2B5EF4-FFF2-40B4-BE49-F238E27FC236}">
-                <a16:creationId xmlns:a16="http://schemas.microsoft.com/office/drawing/2014/main" id="{24B46CE9-103B-4451-80FC-158BA502D50A}"/>
+                <a16:creationId xmlns:a16="http://schemas.microsoft.com/office/drawing/2014/main" id="{AA53FF36-A195-4838-A8FE-AD1689F7BBD5}"/>
               </a:ext>
             </a:extLst>
           </p:cNvPr>
@@ -9806,7 +9806,7 @@
           <p:cNvPr id="4" name="">
             <a:extLst xmlns:a="http://schemas.openxmlformats.org/drawingml/2006/main">
               <a:ext uri="{FF2B5EF4-FFF2-40B4-BE49-F238E27FC236}">
-                <a16:creationId xmlns:a16="http://schemas.microsoft.com/office/drawing/2014/main" id="{C7C537EA-256D-4AEC-AF7D-B57F5E194DF5}"/>
+                <a16:creationId xmlns:a16="http://schemas.microsoft.com/office/drawing/2014/main" id="{AB0996F9-8612-4C94-9623-BD615351559E}"/>
               </a:ext>
             </a:extLst>
           </p:cNvPr>
@@ -9874,7 +9874,7 @@
           <p:cNvPr id="5" name="">
             <a:extLst xmlns:a="http://schemas.openxmlformats.org/drawingml/2006/main">
               <a:ext uri="{FF2B5EF4-FFF2-40B4-BE49-F238E27FC236}">
-                <a16:creationId xmlns:a16="http://schemas.microsoft.com/office/drawing/2014/main" id="{90B19529-80CE-4D96-8409-D6E5E86309DA}"/>
+                <a16:creationId xmlns:a16="http://schemas.microsoft.com/office/drawing/2014/main" id="{4626DF69-F08D-44D8-A801-051CE4F2BA06}"/>
               </a:ext>
             </a:extLst>
           </p:cNvPr>
@@ -9942,7 +9942,7 @@
           <p:cNvPr id="6" name="">
             <a:extLst xmlns:a="http://schemas.openxmlformats.org/drawingml/2006/main">
               <a:ext uri="{FF2B5EF4-FFF2-40B4-BE49-F238E27FC236}">
-                <a16:creationId xmlns:a16="http://schemas.microsoft.com/office/drawing/2014/main" id="{BC9FAD7B-D068-4352-A5B4-89C2BC793099}"/>
+                <a16:creationId xmlns:a16="http://schemas.microsoft.com/office/drawing/2014/main" id="{662D4575-1E11-4CA5-8379-BDACB11E7B09}"/>
               </a:ext>
             </a:extLst>
           </p:cNvPr>
@@ -10010,7 +10010,7 @@
           <p:cNvPr id="7" name="">
             <a:extLst xmlns:a="http://schemas.openxmlformats.org/drawingml/2006/main">
               <a:ext uri="{FF2B5EF4-FFF2-40B4-BE49-F238E27FC236}">
-                <a16:creationId xmlns:a16="http://schemas.microsoft.com/office/drawing/2014/main" id="{5DEC2AAF-4E3C-453C-B095-19587271AFD1}"/>
+                <a16:creationId xmlns:a16="http://schemas.microsoft.com/office/drawing/2014/main" id="{DBBC26BD-849E-4506-B0B4-66BE33F85F3C}"/>
               </a:ext>
             </a:extLst>
           </p:cNvPr>
@@ -10076,7 +10076,7 @@
     </p:spTree>
     <p:extLst>
       <p:ext uri="{BB962C8B-B14F-4D97-AF65-F5344CB8AC3E}">
-        <p14:creationId xmlns:p14="http://schemas.microsoft.com/office/powerpoint/2010/main" val="1144844291"/>
+        <p14:creationId xmlns:p14="http://schemas.microsoft.com/office/powerpoint/2010/main" val="951651134"/>
       </p:ext>
     </p:extLst>
   </p:cSld>
@@ -10107,7 +10107,7 @@
           <p:cNvPr id="5" name="">
             <a:extLst xmlns:a="http://schemas.openxmlformats.org/drawingml/2006/main">
               <a:ext uri="{FF2B5EF4-FFF2-40B4-BE49-F238E27FC236}">
-                <a16:creationId xmlns:a16="http://schemas.microsoft.com/office/drawing/2014/main" id="{0C50C292-3C5D-4765-AB02-890377230BB4}"/>
+                <a16:creationId xmlns:a16="http://schemas.microsoft.com/office/drawing/2014/main" id="{D871B3A7-A187-46E2-BFD6-A78BF307D381}"/>
               </a:ext>
             </a:extLst>
           </p:cNvPr>
@@ -10175,7 +10175,7 @@
           <p:cNvPr id="2" name="">
             <a:extLst xmlns:a="http://schemas.openxmlformats.org/drawingml/2006/main">
               <a:ext uri="{FF2B5EF4-FFF2-40B4-BE49-F238E27FC236}">
-                <a16:creationId xmlns:a16="http://schemas.microsoft.com/office/drawing/2014/main" id="{E661ECE5-9D40-4720-9344-04FA188EF13A}"/>
+                <a16:creationId xmlns:a16="http://schemas.microsoft.com/office/drawing/2014/main" id="{919CAD0A-7C33-4DA5-95DE-5AD499279E41}"/>
               </a:ext>
             </a:extLst>
           </p:cNvPr>
@@ -10243,7 +10243,7 @@
           <p:cNvPr id="3" name="">
             <a:extLst xmlns:a="http://schemas.openxmlformats.org/drawingml/2006/main">
               <a:ext uri="{FF2B5EF4-FFF2-40B4-BE49-F238E27FC236}">
-                <a16:creationId xmlns:a16="http://schemas.microsoft.com/office/drawing/2014/main" id="{FE95265D-1F58-40DB-B36B-B2FC86323CC3}"/>
+                <a16:creationId xmlns:a16="http://schemas.microsoft.com/office/drawing/2014/main" id="{B8D17043-15AA-4212-AEBA-FAECEB0A0A57}"/>
               </a:ext>
             </a:extLst>
           </p:cNvPr>
@@ -10311,7 +10311,7 @@
           <p:cNvPr id="4" name="">
             <a:extLst xmlns:a="http://schemas.openxmlformats.org/drawingml/2006/main">
               <a:ext uri="{FF2B5EF4-FFF2-40B4-BE49-F238E27FC236}">
-                <a16:creationId xmlns:a16="http://schemas.microsoft.com/office/drawing/2014/main" id="{4E3618C5-2046-4FEF-8B63-937049EE1D0D}"/>
+                <a16:creationId xmlns:a16="http://schemas.microsoft.com/office/drawing/2014/main" id="{1C674FB9-B56E-459F-85EC-9ABA606079DA}"/>
               </a:ext>
             </a:extLst>
           </p:cNvPr>
@@ -10936,7 +10936,7 @@
     </p:spTree>
     <p:extLst>
       <p:ext uri="{BB962C8B-B14F-4D97-AF65-F5344CB8AC3E}">
-        <p14:creationId xmlns:p14="http://schemas.microsoft.com/office/powerpoint/2010/main" val="357377443"/>
+        <p14:creationId xmlns:p14="http://schemas.microsoft.com/office/powerpoint/2010/main" val="1196484586"/>
       </p:ext>
     </p:extLst>
   </p:cSld>
@@ -10967,7 +10967,7 @@
           <p:cNvPr id="5" name="">
             <a:extLst xmlns:a="http://schemas.openxmlformats.org/drawingml/2006/main">
               <a:ext uri="{FF2B5EF4-FFF2-40B4-BE49-F238E27FC236}">
-                <a16:creationId xmlns:a16="http://schemas.microsoft.com/office/drawing/2014/main" id="{A975C93D-F818-4E24-B763-78B315A5ECCD}"/>
+                <a16:creationId xmlns:a16="http://schemas.microsoft.com/office/drawing/2014/main" id="{60770451-D226-4572-A31A-C1DDD55F78B0}"/>
               </a:ext>
             </a:extLst>
           </p:cNvPr>
@@ -11025,7 +11025,7 @@
                 <a:ea typeface="Heiti TC"/>
                 <a:cs typeface="Heiti TC"/>
               </a:rPr>
-              <a:t>附錄，主管追問與回答範圍</a:t>
+              <a:t>附錄，技術問題與結果解讀</a:t>
             </a:r>
           </a:p>
         </p:txBody>
@@ -11035,7 +11035,7 @@
           <p:cNvPr id="2" name="">
             <a:extLst xmlns:a="http://schemas.openxmlformats.org/drawingml/2006/main">
               <a:ext uri="{FF2B5EF4-FFF2-40B4-BE49-F238E27FC236}">
-                <a16:creationId xmlns:a16="http://schemas.microsoft.com/office/drawing/2014/main" id="{B1C180CF-32A5-4B2A-8A9A-709524A71D12}"/>
+                <a16:creationId xmlns:a16="http://schemas.microsoft.com/office/drawing/2014/main" id="{EA815088-F2C4-40E6-8C6B-4AFCC7568353}"/>
               </a:ext>
             </a:extLst>
           </p:cNvPr>
@@ -11103,7 +11103,7 @@
           <p:cNvPr id="3" name="">
             <a:extLst xmlns:a="http://schemas.openxmlformats.org/drawingml/2006/main">
               <a:ext uri="{FF2B5EF4-FFF2-40B4-BE49-F238E27FC236}">
-                <a16:creationId xmlns:a16="http://schemas.microsoft.com/office/drawing/2014/main" id="{6B538651-9159-49F6-920F-EE2A436222DC}"/>
+                <a16:creationId xmlns:a16="http://schemas.microsoft.com/office/drawing/2014/main" id="{09847B44-D1BC-4C05-BB1F-184C9EAFDE00}"/>
               </a:ext>
             </a:extLst>
           </p:cNvPr>
@@ -11171,7 +11171,7 @@
           <p:cNvPr id="4" name="">
             <a:extLst xmlns:a="http://schemas.openxmlformats.org/drawingml/2006/main">
               <a:ext uri="{FF2B5EF4-FFF2-40B4-BE49-F238E27FC236}">
-                <a16:creationId xmlns:a16="http://schemas.microsoft.com/office/drawing/2014/main" id="{E759C1AD-307B-4C54-B6D7-A1B4DA8050D9}"/>
+                <a16:creationId xmlns:a16="http://schemas.microsoft.com/office/drawing/2014/main" id="{FC1D7FF0-43A6-49EF-9696-484C573CBAC8}"/>
               </a:ext>
             </a:extLst>
           </p:cNvPr>
@@ -11609,7 +11609,7 @@
     </p:spTree>
     <p:extLst>
       <p:ext uri="{BB962C8B-B14F-4D97-AF65-F5344CB8AC3E}">
-        <p14:creationId xmlns:p14="http://schemas.microsoft.com/office/powerpoint/2010/main" val="1562247704"/>
+        <p14:creationId xmlns:p14="http://schemas.microsoft.com/office/powerpoint/2010/main" val="1430205269"/>
       </p:ext>
     </p:extLst>
   </p:cSld>
@@ -11640,7 +11640,7 @@
           <p:cNvPr id="8" name="">
             <a:extLst xmlns:a="http://schemas.openxmlformats.org/drawingml/2006/main">
               <a:ext uri="{FF2B5EF4-FFF2-40B4-BE49-F238E27FC236}">
-                <a16:creationId xmlns:a16="http://schemas.microsoft.com/office/drawing/2014/main" id="{E21FA47B-93F2-4307-A76A-5AD89F9D0227}"/>
+                <a16:creationId xmlns:a16="http://schemas.microsoft.com/office/drawing/2014/main" id="{A3209082-C548-4E28-AB9C-412741F5AC1E}"/>
               </a:ext>
             </a:extLst>
           </p:cNvPr>
@@ -11708,7 +11708,7 @@
           <p:cNvPr id="2" name="">
             <a:extLst xmlns:a="http://schemas.openxmlformats.org/drawingml/2006/main">
               <a:ext uri="{FF2B5EF4-FFF2-40B4-BE49-F238E27FC236}">
-                <a16:creationId xmlns:a16="http://schemas.microsoft.com/office/drawing/2014/main" id="{E18FB1D3-7FEB-466F-AA0E-9381D5135550}"/>
+                <a16:creationId xmlns:a16="http://schemas.microsoft.com/office/drawing/2014/main" id="{5259CB9F-858D-46BF-B3E1-1F5E27F8E359}"/>
               </a:ext>
             </a:extLst>
           </p:cNvPr>
@@ -11776,7 +11776,7 @@
           <p:cNvPr id="3" name="">
             <a:extLst xmlns:a="http://schemas.openxmlformats.org/drawingml/2006/main">
               <a:ext uri="{FF2B5EF4-FFF2-40B4-BE49-F238E27FC236}">
-                <a16:creationId xmlns:a16="http://schemas.microsoft.com/office/drawing/2014/main" id="{07C265F0-051A-4129-837D-955B6668BE86}"/>
+                <a16:creationId xmlns:a16="http://schemas.microsoft.com/office/drawing/2014/main" id="{CAE0BCC0-6F18-45D7-9CFC-76DB9BDC1D56}"/>
               </a:ext>
             </a:extLst>
           </p:cNvPr>
@@ -11844,7 +11844,7 @@
           <p:cNvPr id="4" name="">
             <a:extLst xmlns:a="http://schemas.openxmlformats.org/drawingml/2006/main">
               <a:ext uri="{FF2B5EF4-FFF2-40B4-BE49-F238E27FC236}">
-                <a16:creationId xmlns:a16="http://schemas.microsoft.com/office/drawing/2014/main" id="{087D3115-3E31-4B21-98E8-4620E67E5CB4}"/>
+                <a16:creationId xmlns:a16="http://schemas.microsoft.com/office/drawing/2014/main" id="{CBFB23B6-4B4A-42F3-9980-D3EE86818FB2}"/>
               </a:ext>
             </a:extLst>
           </p:cNvPr>
@@ -11912,7 +11912,7 @@
           <p:cNvPr id="5" name="">
             <a:extLst xmlns:a="http://schemas.openxmlformats.org/drawingml/2006/main">
               <a:ext uri="{FF2B5EF4-FFF2-40B4-BE49-F238E27FC236}">
-                <a16:creationId xmlns:a16="http://schemas.microsoft.com/office/drawing/2014/main" id="{6A911166-BBF2-4162-A336-8339EC53C3F0}"/>
+                <a16:creationId xmlns:a16="http://schemas.microsoft.com/office/drawing/2014/main" id="{225485B1-DCCD-4EDB-A016-A696EE08FF89}"/>
               </a:ext>
             </a:extLst>
           </p:cNvPr>
@@ -11980,7 +11980,7 @@
           <p:cNvPr id="6" name="">
             <a:extLst xmlns:a="http://schemas.openxmlformats.org/drawingml/2006/main">
               <a:ext uri="{FF2B5EF4-FFF2-40B4-BE49-F238E27FC236}">
-                <a16:creationId xmlns:a16="http://schemas.microsoft.com/office/drawing/2014/main" id="{7AF24613-930D-48F5-A76D-A47933A46F12}"/>
+                <a16:creationId xmlns:a16="http://schemas.microsoft.com/office/drawing/2014/main" id="{2545295F-96B6-4823-A76A-B346C7653ACD}"/>
               </a:ext>
             </a:extLst>
           </p:cNvPr>
@@ -12048,7 +12048,7 @@
           <p:cNvPr id="7" name="">
             <a:extLst xmlns:a="http://schemas.openxmlformats.org/drawingml/2006/main">
               <a:ext uri="{FF2B5EF4-FFF2-40B4-BE49-F238E27FC236}">
-                <a16:creationId xmlns:a16="http://schemas.microsoft.com/office/drawing/2014/main" id="{1C9C296A-9AB9-460E-B9E2-116F713A4347}"/>
+                <a16:creationId xmlns:a16="http://schemas.microsoft.com/office/drawing/2014/main" id="{6C1FBB01-2E05-4FE3-BE78-2070630E227C}"/>
               </a:ext>
             </a:extLst>
           </p:cNvPr>
@@ -12114,7 +12114,7 @@
     </p:spTree>
     <p:extLst>
       <p:ext uri="{BB962C8B-B14F-4D97-AF65-F5344CB8AC3E}">
-        <p14:creationId xmlns:p14="http://schemas.microsoft.com/office/powerpoint/2010/main" val="262590507"/>
+        <p14:creationId xmlns:p14="http://schemas.microsoft.com/office/powerpoint/2010/main" val="779479463"/>
       </p:ext>
     </p:extLst>
   </p:cSld>
@@ -12145,7 +12145,7 @@
           <p:cNvPr id="7" name="">
             <a:extLst xmlns:a="http://schemas.openxmlformats.org/drawingml/2006/main">
               <a:ext uri="{FF2B5EF4-FFF2-40B4-BE49-F238E27FC236}">
-                <a16:creationId xmlns:a16="http://schemas.microsoft.com/office/drawing/2014/main" id="{99A90E84-A44F-414B-8B00-38F72FA9443E}"/>
+                <a16:creationId xmlns:a16="http://schemas.microsoft.com/office/drawing/2014/main" id="{99FD8F94-B4C1-4F5A-BE74-139491068475}"/>
               </a:ext>
             </a:extLst>
           </p:cNvPr>
@@ -12213,7 +12213,7 @@
           <p:cNvPr id="2" name="">
             <a:extLst xmlns:a="http://schemas.openxmlformats.org/drawingml/2006/main">
               <a:ext uri="{FF2B5EF4-FFF2-40B4-BE49-F238E27FC236}">
-                <a16:creationId xmlns:a16="http://schemas.microsoft.com/office/drawing/2014/main" id="{473339FF-D04B-41DC-9809-CEAD5A577AA9}"/>
+                <a16:creationId xmlns:a16="http://schemas.microsoft.com/office/drawing/2014/main" id="{DF7EF092-1E48-455E-83EB-8AD56090D019}"/>
               </a:ext>
             </a:extLst>
           </p:cNvPr>
@@ -12281,7 +12281,7 @@
           <p:cNvPr id="3" name="">
             <a:extLst xmlns:a="http://schemas.openxmlformats.org/drawingml/2006/main">
               <a:ext uri="{FF2B5EF4-FFF2-40B4-BE49-F238E27FC236}">
-                <a16:creationId xmlns:a16="http://schemas.microsoft.com/office/drawing/2014/main" id="{27F8B6B9-D626-4C80-901B-3DD1E3054DC4}"/>
+                <a16:creationId xmlns:a16="http://schemas.microsoft.com/office/drawing/2014/main" id="{B412F07F-CA0D-4418-A662-001499CA95E1}"/>
               </a:ext>
             </a:extLst>
           </p:cNvPr>
@@ -12349,7 +12349,7 @@
           <p:cNvPr id="4" name="">
             <a:extLst xmlns:a="http://schemas.openxmlformats.org/drawingml/2006/main">
               <a:ext uri="{FF2B5EF4-FFF2-40B4-BE49-F238E27FC236}">
-                <a16:creationId xmlns:a16="http://schemas.microsoft.com/office/drawing/2014/main" id="{CD6580D4-A253-47AA-B0B7-566D1B3B9369}"/>
+                <a16:creationId xmlns:a16="http://schemas.microsoft.com/office/drawing/2014/main" id="{A3BACE4B-46F5-4810-805B-0E3493E68BBD}"/>
               </a:ext>
             </a:extLst>
           </p:cNvPr>
@@ -12417,7 +12417,7 @@
           <p:cNvPr id="5" name="">
             <a:extLst xmlns:a="http://schemas.openxmlformats.org/drawingml/2006/main">
               <a:ext uri="{FF2B5EF4-FFF2-40B4-BE49-F238E27FC236}">
-                <a16:creationId xmlns:a16="http://schemas.microsoft.com/office/drawing/2014/main" id="{FE9864E4-BB8B-478A-8F8E-A1510917394F}"/>
+                <a16:creationId xmlns:a16="http://schemas.microsoft.com/office/drawing/2014/main" id="{5D883690-B4A3-4ABA-9608-33862A02A405}"/>
               </a:ext>
             </a:extLst>
           </p:cNvPr>
@@ -12531,7 +12531,7 @@
           <p:cNvPr id="6" name="">
             <a:extLst xmlns:a="http://schemas.openxmlformats.org/drawingml/2006/main">
               <a:ext uri="{FF2B5EF4-FFF2-40B4-BE49-F238E27FC236}">
-                <a16:creationId xmlns:a16="http://schemas.microsoft.com/office/drawing/2014/main" id="{C4912416-4094-4135-A308-70EB4C107CF2}"/>
+                <a16:creationId xmlns:a16="http://schemas.microsoft.com/office/drawing/2014/main" id="{CDBD541C-16B0-49B9-ACA7-2843DC7B71A6}"/>
               </a:ext>
             </a:extLst>
           </p:cNvPr>
@@ -12597,7 +12597,7 @@
     </p:spTree>
     <p:extLst>
       <p:ext uri="{BB962C8B-B14F-4D97-AF65-F5344CB8AC3E}">
-        <p14:creationId xmlns:p14="http://schemas.microsoft.com/office/powerpoint/2010/main" val="1868204109"/>
+        <p14:creationId xmlns:p14="http://schemas.microsoft.com/office/powerpoint/2010/main" val="1654701536"/>
       </p:ext>
     </p:extLst>
   </p:cSld>
@@ -12628,7 +12628,7 @@
           <p:cNvPr id="5" name="">
             <a:extLst xmlns:a="http://schemas.openxmlformats.org/drawingml/2006/main">
               <a:ext uri="{FF2B5EF4-FFF2-40B4-BE49-F238E27FC236}">
-                <a16:creationId xmlns:a16="http://schemas.microsoft.com/office/drawing/2014/main" id="{52A2543D-A24A-4151-817D-6EDAE5E623B0}"/>
+                <a16:creationId xmlns:a16="http://schemas.microsoft.com/office/drawing/2014/main" id="{140EAA08-E474-42EA-8049-554711E224F5}"/>
               </a:ext>
             </a:extLst>
           </p:cNvPr>
@@ -12696,7 +12696,7 @@
           <p:cNvPr id="2" name="">
             <a:extLst xmlns:a="http://schemas.openxmlformats.org/drawingml/2006/main">
               <a:ext uri="{FF2B5EF4-FFF2-40B4-BE49-F238E27FC236}">
-                <a16:creationId xmlns:a16="http://schemas.microsoft.com/office/drawing/2014/main" id="{6D349B38-4E41-45F0-BAFB-BA841C5943F8}"/>
+                <a16:creationId xmlns:a16="http://schemas.microsoft.com/office/drawing/2014/main" id="{641BB61C-2C5D-4ECE-A673-389B80A84B81}"/>
               </a:ext>
             </a:extLst>
           </p:cNvPr>
@@ -12764,7 +12764,7 @@
           <p:cNvPr id="3" name="">
             <a:extLst xmlns:a="http://schemas.openxmlformats.org/drawingml/2006/main">
               <a:ext uri="{FF2B5EF4-FFF2-40B4-BE49-F238E27FC236}">
-                <a16:creationId xmlns:a16="http://schemas.microsoft.com/office/drawing/2014/main" id="{6931C048-E8B8-4A54-9B48-A828AC887223}"/>
+                <a16:creationId xmlns:a16="http://schemas.microsoft.com/office/drawing/2014/main" id="{7904E922-BAC8-4935-BAFD-5FE080264323}"/>
               </a:ext>
             </a:extLst>
           </p:cNvPr>
@@ -12832,7 +12832,7 @@
           <p:cNvPr id="4" name="">
             <a:extLst xmlns:a="http://schemas.openxmlformats.org/drawingml/2006/main">
               <a:ext uri="{FF2B5EF4-FFF2-40B4-BE49-F238E27FC236}">
-                <a16:creationId xmlns:a16="http://schemas.microsoft.com/office/drawing/2014/main" id="{97A62A65-9E12-48A0-BC71-5EE5A006B683}"/>
+                <a16:creationId xmlns:a16="http://schemas.microsoft.com/office/drawing/2014/main" id="{D7E442DA-81CE-43C7-9CA0-FFE3372E2B80}"/>
               </a:ext>
             </a:extLst>
           </p:cNvPr>
@@ -13457,7 +13457,7 @@
     </p:spTree>
     <p:extLst>
       <p:ext uri="{BB962C8B-B14F-4D97-AF65-F5344CB8AC3E}">
-        <p14:creationId xmlns:p14="http://schemas.microsoft.com/office/powerpoint/2010/main" val="1108545497"/>
+        <p14:creationId xmlns:p14="http://schemas.microsoft.com/office/powerpoint/2010/main" val="1462102320"/>
       </p:ext>
     </p:extLst>
   </p:cSld>
@@ -13488,7 +13488,7 @@
           <p:cNvPr id="7" name="">
             <a:extLst xmlns:a="http://schemas.openxmlformats.org/drawingml/2006/main">
               <a:ext uri="{FF2B5EF4-FFF2-40B4-BE49-F238E27FC236}">
-                <a16:creationId xmlns:a16="http://schemas.microsoft.com/office/drawing/2014/main" id="{3A48F11E-46D1-470D-BC0B-88FD89443F2A}"/>
+                <a16:creationId xmlns:a16="http://schemas.microsoft.com/office/drawing/2014/main" id="{13AB847E-94B2-4A3B-AC86-5242AAE95EE7}"/>
               </a:ext>
             </a:extLst>
           </p:cNvPr>
@@ -13556,7 +13556,7 @@
           <p:cNvPr id="2" name="">
             <a:extLst xmlns:a="http://schemas.openxmlformats.org/drawingml/2006/main">
               <a:ext uri="{FF2B5EF4-FFF2-40B4-BE49-F238E27FC236}">
-                <a16:creationId xmlns:a16="http://schemas.microsoft.com/office/drawing/2014/main" id="{FF8140DC-383C-4999-835B-3F446A145B24}"/>
+                <a16:creationId xmlns:a16="http://schemas.microsoft.com/office/drawing/2014/main" id="{0466AE9C-1BAC-40F7-98B5-0320AACDBD73}"/>
               </a:ext>
             </a:extLst>
           </p:cNvPr>
@@ -13624,7 +13624,7 @@
           <p:cNvPr id="3" name="">
             <a:extLst xmlns:a="http://schemas.openxmlformats.org/drawingml/2006/main">
               <a:ext uri="{FF2B5EF4-FFF2-40B4-BE49-F238E27FC236}">
-                <a16:creationId xmlns:a16="http://schemas.microsoft.com/office/drawing/2014/main" id="{65A13703-FA17-4BB2-9163-97D04F2B6F12}"/>
+                <a16:creationId xmlns:a16="http://schemas.microsoft.com/office/drawing/2014/main" id="{1F88AEAB-A79A-4BC8-8579-5AF383F3A0B9}"/>
               </a:ext>
             </a:extLst>
           </p:cNvPr>
@@ -13692,7 +13692,7 @@
           <p:cNvPr id="4" name="">
             <a:extLst xmlns:a="http://schemas.openxmlformats.org/drawingml/2006/main">
               <a:ext uri="{FF2B5EF4-FFF2-40B4-BE49-F238E27FC236}">
-                <a16:creationId xmlns:a16="http://schemas.microsoft.com/office/drawing/2014/main" id="{14344955-A7F2-409D-A2A3-6A89CCDB5DE3}"/>
+                <a16:creationId xmlns:a16="http://schemas.microsoft.com/office/drawing/2014/main" id="{175F4328-C6B1-49B2-AB23-61564D8F2BCA}"/>
               </a:ext>
             </a:extLst>
           </p:cNvPr>
@@ -13760,7 +13760,7 @@
           <p:cNvPr id="5" name="">
             <a:extLst xmlns:a="http://schemas.openxmlformats.org/drawingml/2006/main">
               <a:ext uri="{FF2B5EF4-FFF2-40B4-BE49-F238E27FC236}">
-                <a16:creationId xmlns:a16="http://schemas.microsoft.com/office/drawing/2014/main" id="{99C587A0-02EC-400C-BCCE-CE6D829241F6}"/>
+                <a16:creationId xmlns:a16="http://schemas.microsoft.com/office/drawing/2014/main" id="{6C6D353C-A188-4853-81FC-73F33767ACF1}"/>
               </a:ext>
             </a:extLst>
           </p:cNvPr>
@@ -14271,7 +14271,7 @@
           <p:cNvPr id="6" name="">
             <a:extLst xmlns:a="http://schemas.openxmlformats.org/drawingml/2006/main">
               <a:ext uri="{FF2B5EF4-FFF2-40B4-BE49-F238E27FC236}">
-                <a16:creationId xmlns:a16="http://schemas.microsoft.com/office/drawing/2014/main" id="{34BA03E2-B54F-4852-BA11-B52F0C3D8F75}"/>
+                <a16:creationId xmlns:a16="http://schemas.microsoft.com/office/drawing/2014/main" id="{CA009917-F5E1-401F-AB51-30A6AC84C646}"/>
               </a:ext>
             </a:extLst>
           </p:cNvPr>
@@ -14337,7 +14337,7 @@
     </p:spTree>
     <p:extLst>
       <p:ext uri="{BB962C8B-B14F-4D97-AF65-F5344CB8AC3E}">
-        <p14:creationId xmlns:p14="http://schemas.microsoft.com/office/powerpoint/2010/main" val="1821218369"/>
+        <p14:creationId xmlns:p14="http://schemas.microsoft.com/office/powerpoint/2010/main" val="247621615"/>
       </p:ext>
     </p:extLst>
   </p:cSld>
@@ -14368,7 +14368,7 @@
           <p:cNvPr id="6" name="">
             <a:extLst xmlns:a="http://schemas.openxmlformats.org/drawingml/2006/main">
               <a:ext uri="{FF2B5EF4-FFF2-40B4-BE49-F238E27FC236}">
-                <a16:creationId xmlns:a16="http://schemas.microsoft.com/office/drawing/2014/main" id="{B7BA6E90-3C64-4804-B8A2-ADCD76B0FE57}"/>
+                <a16:creationId xmlns:a16="http://schemas.microsoft.com/office/drawing/2014/main" id="{013A59FA-2A88-4BA0-AA40-94E87F3AA8BE}"/>
               </a:ext>
             </a:extLst>
           </p:cNvPr>
@@ -14436,7 +14436,7 @@
           <p:cNvPr id="2" name="">
             <a:extLst xmlns:a="http://schemas.openxmlformats.org/drawingml/2006/main">
               <a:ext uri="{FF2B5EF4-FFF2-40B4-BE49-F238E27FC236}">
-                <a16:creationId xmlns:a16="http://schemas.microsoft.com/office/drawing/2014/main" id="{AA505396-CEF2-45FC-AAD3-9FBE517EDB51}"/>
+                <a16:creationId xmlns:a16="http://schemas.microsoft.com/office/drawing/2014/main" id="{74D7BAE3-A227-4AC7-83B3-CFDD0AE68A12}"/>
               </a:ext>
             </a:extLst>
           </p:cNvPr>
@@ -14504,7 +14504,7 @@
           <p:cNvPr id="3" name="">
             <a:extLst xmlns:a="http://schemas.openxmlformats.org/drawingml/2006/main">
               <a:ext uri="{FF2B5EF4-FFF2-40B4-BE49-F238E27FC236}">
-                <a16:creationId xmlns:a16="http://schemas.microsoft.com/office/drawing/2014/main" id="{BCA6A7F7-3847-4BE9-8D0B-5AD65940AF16}"/>
+                <a16:creationId xmlns:a16="http://schemas.microsoft.com/office/drawing/2014/main" id="{E7B61690-4B9F-4099-B172-F4D4E10A63CE}"/>
               </a:ext>
             </a:extLst>
           </p:cNvPr>
@@ -14572,7 +14572,7 @@
           <p:cNvPr id="4" name="">
             <a:extLst xmlns:a="http://schemas.openxmlformats.org/drawingml/2006/main">
               <a:ext uri="{FF2B5EF4-FFF2-40B4-BE49-F238E27FC236}">
-                <a16:creationId xmlns:a16="http://schemas.microsoft.com/office/drawing/2014/main" id="{577259D1-E3B1-4DB0-B1BB-F2578D5BA4C3}"/>
+                <a16:creationId xmlns:a16="http://schemas.microsoft.com/office/drawing/2014/main" id="{91F1D5D4-79E7-403A-966F-091C8C9D84B0}"/>
               </a:ext>
             </a:extLst>
           </p:cNvPr>
@@ -15234,7 +15234,7 @@
           <p:cNvPr id="5" name="">
             <a:extLst xmlns:a="http://schemas.openxmlformats.org/drawingml/2006/main">
               <a:ext uri="{FF2B5EF4-FFF2-40B4-BE49-F238E27FC236}">
-                <a16:creationId xmlns:a16="http://schemas.microsoft.com/office/drawing/2014/main" id="{08AF414F-BD9E-49A2-96A3-BECAFCC3A2A0}"/>
+                <a16:creationId xmlns:a16="http://schemas.microsoft.com/office/drawing/2014/main" id="{B1EE1DAB-6A7F-4230-AA7F-E15EC2D64A84}"/>
               </a:ext>
             </a:extLst>
           </p:cNvPr>
@@ -15300,7 +15300,7 @@
     </p:spTree>
     <p:extLst>
       <p:ext uri="{BB962C8B-B14F-4D97-AF65-F5344CB8AC3E}">
-        <p14:creationId xmlns:p14="http://schemas.microsoft.com/office/powerpoint/2010/main" val="577004057"/>
+        <p14:creationId xmlns:p14="http://schemas.microsoft.com/office/powerpoint/2010/main" val="865843412"/>
       </p:ext>
     </p:extLst>
   </p:cSld>
@@ -15331,7 +15331,7 @@
           <p:cNvPr id="5" name="">
             <a:extLst xmlns:a="http://schemas.openxmlformats.org/drawingml/2006/main">
               <a:ext uri="{FF2B5EF4-FFF2-40B4-BE49-F238E27FC236}">
-                <a16:creationId xmlns:a16="http://schemas.microsoft.com/office/drawing/2014/main" id="{216C2002-58FB-450E-A20E-56E900C265A9}"/>
+                <a16:creationId xmlns:a16="http://schemas.microsoft.com/office/drawing/2014/main" id="{1F1B1696-B8F2-4480-A0FC-FA465E2CB7A0}"/>
               </a:ext>
             </a:extLst>
           </p:cNvPr>
@@ -15399,7 +15399,7 @@
           <p:cNvPr id="2" name="">
             <a:extLst xmlns:a="http://schemas.openxmlformats.org/drawingml/2006/main">
               <a:ext uri="{FF2B5EF4-FFF2-40B4-BE49-F238E27FC236}">
-                <a16:creationId xmlns:a16="http://schemas.microsoft.com/office/drawing/2014/main" id="{12F6A1DB-26BE-4D5C-954F-9778B6048A5C}"/>
+                <a16:creationId xmlns:a16="http://schemas.microsoft.com/office/drawing/2014/main" id="{0B756649-0E42-4C71-976B-97A26ABA1483}"/>
               </a:ext>
             </a:extLst>
           </p:cNvPr>
@@ -15467,7 +15467,7 @@
           <p:cNvPr id="3" name="">
             <a:extLst xmlns:a="http://schemas.openxmlformats.org/drawingml/2006/main">
               <a:ext uri="{FF2B5EF4-FFF2-40B4-BE49-F238E27FC236}">
-                <a16:creationId xmlns:a16="http://schemas.microsoft.com/office/drawing/2014/main" id="{78A364D7-6AA4-42EE-83BD-BCA025DA4D02}"/>
+                <a16:creationId xmlns:a16="http://schemas.microsoft.com/office/drawing/2014/main" id="{2B7DAF18-1D76-4C15-90D5-12A6EE43E03D}"/>
               </a:ext>
             </a:extLst>
           </p:cNvPr>
@@ -15535,7 +15535,7 @@
           <p:cNvPr id="4" name="">
             <a:extLst xmlns:a="http://schemas.openxmlformats.org/drawingml/2006/main">
               <a:ext uri="{FF2B5EF4-FFF2-40B4-BE49-F238E27FC236}">
-                <a16:creationId xmlns:a16="http://schemas.microsoft.com/office/drawing/2014/main" id="{0F1DDB32-38A5-4638-8B23-DDCBACD04B82}"/>
+                <a16:creationId xmlns:a16="http://schemas.microsoft.com/office/drawing/2014/main" id="{D9FD9B21-DC2E-4B27-80E8-1F070E67267D}"/>
               </a:ext>
             </a:extLst>
           </p:cNvPr>
@@ -16160,7 +16160,7 @@
     </p:spTree>
     <p:extLst>
       <p:ext uri="{BB962C8B-B14F-4D97-AF65-F5344CB8AC3E}">
-        <p14:creationId xmlns:p14="http://schemas.microsoft.com/office/powerpoint/2010/main" val="1414591796"/>
+        <p14:creationId xmlns:p14="http://schemas.microsoft.com/office/powerpoint/2010/main" val="433598792"/>
       </p:ext>
     </p:extLst>
   </p:cSld>
@@ -16191,7 +16191,7 @@
           <p:cNvPr id="8" name="">
             <a:extLst xmlns:a="http://schemas.openxmlformats.org/drawingml/2006/main">
               <a:ext uri="{FF2B5EF4-FFF2-40B4-BE49-F238E27FC236}">
-                <a16:creationId xmlns:a16="http://schemas.microsoft.com/office/drawing/2014/main" id="{27133FF1-AE57-434B-92C5-E5A290887A54}"/>
+                <a16:creationId xmlns:a16="http://schemas.microsoft.com/office/drawing/2014/main" id="{6DB1E869-FF96-4891-8B04-107B98A6DE2F}"/>
               </a:ext>
             </a:extLst>
           </p:cNvPr>
@@ -16259,7 +16259,7 @@
           <p:cNvPr id="2" name="">
             <a:extLst xmlns:a="http://schemas.openxmlformats.org/drawingml/2006/main">
               <a:ext uri="{FF2B5EF4-FFF2-40B4-BE49-F238E27FC236}">
-                <a16:creationId xmlns:a16="http://schemas.microsoft.com/office/drawing/2014/main" id="{B66F8227-CDEB-48B5-8064-D94CF135B307}"/>
+                <a16:creationId xmlns:a16="http://schemas.microsoft.com/office/drawing/2014/main" id="{137CB137-FA13-457A-BED9-A1230E1F86F3}"/>
               </a:ext>
             </a:extLst>
           </p:cNvPr>
@@ -16327,7 +16327,7 @@
           <p:cNvPr id="3" name="">
             <a:extLst xmlns:a="http://schemas.openxmlformats.org/drawingml/2006/main">
               <a:ext uri="{FF2B5EF4-FFF2-40B4-BE49-F238E27FC236}">
-                <a16:creationId xmlns:a16="http://schemas.microsoft.com/office/drawing/2014/main" id="{8C2EE201-65A3-48DC-ABC5-DE23E5F78CB4}"/>
+                <a16:creationId xmlns:a16="http://schemas.microsoft.com/office/drawing/2014/main" id="{6EEB410F-E59A-493E-B586-CF3B21F0C5CD}"/>
               </a:ext>
             </a:extLst>
           </p:cNvPr>
@@ -16395,7 +16395,7 @@
           <p:cNvPr id="4" name="Chart">
             <a:extLst xmlns:a="http://schemas.openxmlformats.org/drawingml/2006/main">
               <a:ext uri="{FF2B5EF4-FFF2-40B4-BE49-F238E27FC236}">
-                <a16:creationId xmlns:a16="http://schemas.microsoft.com/office/drawing/2014/main" id="{56763932-3EDD-4FB7-A93F-411A1FF85553}"/>
+                <a16:creationId xmlns:a16="http://schemas.microsoft.com/office/drawing/2014/main" id="{B7127142-CA48-42AA-893F-8BA745F4E35D}"/>
               </a:ext>
             </a:extLst>
           </p:cNvPr>
@@ -16408,7 +16408,7 @@
         </p:xfrm>
         <a:graphic xmlns:a="http://schemas.openxmlformats.org/drawingml/2006/main">
           <a:graphicData uri="http://schemas.openxmlformats.org/drawingml/2006/chart">
-            <c:chart xmlns:r="http://schemas.openxmlformats.org/officeDocument/2006/relationships" xmlns:c="http://schemas.openxmlformats.org/drawingml/2006/chart" r:id="Rdcee0d478b464d94"/>
+            <c:chart xmlns:r="http://schemas.openxmlformats.org/officeDocument/2006/relationships" xmlns:c="http://schemas.openxmlformats.org/drawingml/2006/chart" r:id="R277f31cb835349bd"/>
           </a:graphicData>
         </a:graphic>
       </p:graphicFrame>
@@ -16417,7 +16417,7 @@
           <p:cNvPr id="5" name="">
             <a:extLst xmlns:a="http://schemas.openxmlformats.org/drawingml/2006/main">
               <a:ext uri="{FF2B5EF4-FFF2-40B4-BE49-F238E27FC236}">
-                <a16:creationId xmlns:a16="http://schemas.microsoft.com/office/drawing/2014/main" id="{4D65ABAC-8BA3-48B3-84F8-2720AAA668D6}"/>
+                <a16:creationId xmlns:a16="http://schemas.microsoft.com/office/drawing/2014/main" id="{637C266D-658F-485E-8280-CE460F0A293A}"/>
               </a:ext>
             </a:extLst>
           </p:cNvPr>
@@ -16531,7 +16531,7 @@
           <p:cNvPr id="6" name="">
             <a:extLst xmlns:a="http://schemas.openxmlformats.org/drawingml/2006/main">
               <a:ext uri="{FF2B5EF4-FFF2-40B4-BE49-F238E27FC236}">
-                <a16:creationId xmlns:a16="http://schemas.microsoft.com/office/drawing/2014/main" id="{1B3F81A8-6CE0-4C61-A8CD-5CDDCC05102A}"/>
+                <a16:creationId xmlns:a16="http://schemas.microsoft.com/office/drawing/2014/main" id="{AC3F822F-E860-45A8-B1D6-BB90C7565ED0}"/>
               </a:ext>
             </a:extLst>
           </p:cNvPr>
@@ -16645,7 +16645,7 @@
           <p:cNvPr id="7" name="">
             <a:extLst xmlns:a="http://schemas.openxmlformats.org/drawingml/2006/main">
               <a:ext uri="{FF2B5EF4-FFF2-40B4-BE49-F238E27FC236}">
-                <a16:creationId xmlns:a16="http://schemas.microsoft.com/office/drawing/2014/main" id="{4110596D-56CA-4298-B749-FB3C3A902B3E}"/>
+                <a16:creationId xmlns:a16="http://schemas.microsoft.com/office/drawing/2014/main" id="{81A4D3C7-FF02-4A54-8CD3-4595A79D6134}"/>
               </a:ext>
             </a:extLst>
           </p:cNvPr>
@@ -16711,7 +16711,7 @@
     </p:spTree>
     <p:extLst>
       <p:ext uri="{BB962C8B-B14F-4D97-AF65-F5344CB8AC3E}">
-        <p14:creationId xmlns:p14="http://schemas.microsoft.com/office/powerpoint/2010/main" val="797225139"/>
+        <p14:creationId xmlns:p14="http://schemas.microsoft.com/office/powerpoint/2010/main" val="1068146219"/>
       </p:ext>
     </p:extLst>
   </p:cSld>
@@ -16742,7 +16742,7 @@
           <p:cNvPr id="8" name="">
             <a:extLst xmlns:a="http://schemas.openxmlformats.org/drawingml/2006/main">
               <a:ext uri="{FF2B5EF4-FFF2-40B4-BE49-F238E27FC236}">
-                <a16:creationId xmlns:a16="http://schemas.microsoft.com/office/drawing/2014/main" id="{45630176-54A7-4619-B22C-8DF72BDAFDAF}"/>
+                <a16:creationId xmlns:a16="http://schemas.microsoft.com/office/drawing/2014/main" id="{AD0F0D89-8FEA-413D-9F20-D3FCFEF36657}"/>
               </a:ext>
             </a:extLst>
           </p:cNvPr>
@@ -16810,7 +16810,7 @@
           <p:cNvPr id="2" name="">
             <a:extLst xmlns:a="http://schemas.openxmlformats.org/drawingml/2006/main">
               <a:ext uri="{FF2B5EF4-FFF2-40B4-BE49-F238E27FC236}">
-                <a16:creationId xmlns:a16="http://schemas.microsoft.com/office/drawing/2014/main" id="{27B6DED8-946F-4069-8168-0BA9935FA320}"/>
+                <a16:creationId xmlns:a16="http://schemas.microsoft.com/office/drawing/2014/main" id="{7D6507E9-3E66-4793-A7AF-B6DF5A4B658B}"/>
               </a:ext>
             </a:extLst>
           </p:cNvPr>
@@ -16878,7 +16878,7 @@
           <p:cNvPr id="3" name="">
             <a:extLst xmlns:a="http://schemas.openxmlformats.org/drawingml/2006/main">
               <a:ext uri="{FF2B5EF4-FFF2-40B4-BE49-F238E27FC236}">
-                <a16:creationId xmlns:a16="http://schemas.microsoft.com/office/drawing/2014/main" id="{6F830F97-2A6A-4198-8CA5-836EC2E4D771}"/>
+                <a16:creationId xmlns:a16="http://schemas.microsoft.com/office/drawing/2014/main" id="{E4B017DB-F171-4F31-A489-2EFD7AA77F03}"/>
               </a:ext>
             </a:extLst>
           </p:cNvPr>
@@ -16946,7 +16946,7 @@
           <p:cNvPr id="4" name="Chart">
             <a:extLst xmlns:a="http://schemas.openxmlformats.org/drawingml/2006/main">
               <a:ext uri="{FF2B5EF4-FFF2-40B4-BE49-F238E27FC236}">
-                <a16:creationId xmlns:a16="http://schemas.microsoft.com/office/drawing/2014/main" id="{C5D8D143-900E-40DF-B037-4FDBAD9C0C53}"/>
+                <a16:creationId xmlns:a16="http://schemas.microsoft.com/office/drawing/2014/main" id="{AE4B6C5F-C8BF-4038-9EC8-3F61282F5B28}"/>
               </a:ext>
             </a:extLst>
           </p:cNvPr>
@@ -16959,7 +16959,7 @@
         </p:xfrm>
         <a:graphic xmlns:a="http://schemas.openxmlformats.org/drawingml/2006/main">
           <a:graphicData uri="http://schemas.openxmlformats.org/drawingml/2006/chart">
-            <c:chart xmlns:r="http://schemas.openxmlformats.org/officeDocument/2006/relationships" xmlns:c="http://schemas.openxmlformats.org/drawingml/2006/chart" r:id="R144695288040454d"/>
+            <c:chart xmlns:r="http://schemas.openxmlformats.org/officeDocument/2006/relationships" xmlns:c="http://schemas.openxmlformats.org/drawingml/2006/chart" r:id="Rb45e35f1dee2487d"/>
           </a:graphicData>
         </a:graphic>
       </p:graphicFrame>
@@ -16968,7 +16968,7 @@
           <p:cNvPr id="5" name="">
             <a:extLst xmlns:a="http://schemas.openxmlformats.org/drawingml/2006/main">
               <a:ext uri="{FF2B5EF4-FFF2-40B4-BE49-F238E27FC236}">
-                <a16:creationId xmlns:a16="http://schemas.microsoft.com/office/drawing/2014/main" id="{8038C366-2636-4FBB-BC53-26EFEA724498}"/>
+                <a16:creationId xmlns:a16="http://schemas.microsoft.com/office/drawing/2014/main" id="{BEA63B6A-D7E7-46F8-B4FE-9123843AD4EE}"/>
               </a:ext>
             </a:extLst>
           </p:cNvPr>
@@ -17059,7 +17059,7 @@
           <p:cNvPr id="6" name="">
             <a:extLst xmlns:a="http://schemas.openxmlformats.org/drawingml/2006/main">
               <a:ext uri="{FF2B5EF4-FFF2-40B4-BE49-F238E27FC236}">
-                <a16:creationId xmlns:a16="http://schemas.microsoft.com/office/drawing/2014/main" id="{1499EEBE-4C5F-4C08-B7A8-30767BC8470C}"/>
+                <a16:creationId xmlns:a16="http://schemas.microsoft.com/office/drawing/2014/main" id="{F7CA357E-917A-4684-85CF-363D8566CC8F}"/>
               </a:ext>
             </a:extLst>
           </p:cNvPr>
@@ -17150,7 +17150,7 @@
           <p:cNvPr id="7" name="">
             <a:extLst xmlns:a="http://schemas.openxmlformats.org/drawingml/2006/main">
               <a:ext uri="{FF2B5EF4-FFF2-40B4-BE49-F238E27FC236}">
-                <a16:creationId xmlns:a16="http://schemas.microsoft.com/office/drawing/2014/main" id="{464E45A3-97DA-487F-AA0B-F675564AE860}"/>
+                <a16:creationId xmlns:a16="http://schemas.microsoft.com/office/drawing/2014/main" id="{A72B8295-7B2B-47AC-A306-7CECA17B6D47}"/>
               </a:ext>
             </a:extLst>
           </p:cNvPr>
@@ -17216,7 +17216,7 @@
     </p:spTree>
     <p:extLst>
       <p:ext uri="{BB962C8B-B14F-4D97-AF65-F5344CB8AC3E}">
-        <p14:creationId xmlns:p14="http://schemas.microsoft.com/office/powerpoint/2010/main" val="2079960319"/>
+        <p14:creationId xmlns:p14="http://schemas.microsoft.com/office/powerpoint/2010/main" val="1140091082"/>
       </p:ext>
     </p:extLst>
   </p:cSld>
@@ -17247,7 +17247,7 @@
           <p:cNvPr id="7" name="">
             <a:extLst xmlns:a="http://schemas.openxmlformats.org/drawingml/2006/main">
               <a:ext uri="{FF2B5EF4-FFF2-40B4-BE49-F238E27FC236}">
-                <a16:creationId xmlns:a16="http://schemas.microsoft.com/office/drawing/2014/main" id="{45E0A48B-5CB1-4C2C-933C-27EAB78B4EA1}"/>
+                <a16:creationId xmlns:a16="http://schemas.microsoft.com/office/drawing/2014/main" id="{6858756D-829B-4274-AA2B-E6F8260C2533}"/>
               </a:ext>
             </a:extLst>
           </p:cNvPr>
@@ -17315,7 +17315,7 @@
           <p:cNvPr id="2" name="">
             <a:extLst xmlns:a="http://schemas.openxmlformats.org/drawingml/2006/main">
               <a:ext uri="{FF2B5EF4-FFF2-40B4-BE49-F238E27FC236}">
-                <a16:creationId xmlns:a16="http://schemas.microsoft.com/office/drawing/2014/main" id="{0428C802-2C86-4B30-950C-8FD7E2715160}"/>
+                <a16:creationId xmlns:a16="http://schemas.microsoft.com/office/drawing/2014/main" id="{67AF9FDD-E85B-46E5-9AC1-9A9BB300AFCC}"/>
               </a:ext>
             </a:extLst>
           </p:cNvPr>
@@ -17383,7 +17383,7 @@
           <p:cNvPr id="3" name="">
             <a:extLst xmlns:a="http://schemas.openxmlformats.org/drawingml/2006/main">
               <a:ext uri="{FF2B5EF4-FFF2-40B4-BE49-F238E27FC236}">
-                <a16:creationId xmlns:a16="http://schemas.microsoft.com/office/drawing/2014/main" id="{5D58EA5B-0A25-4F3B-B815-8BF2C455376E}"/>
+                <a16:creationId xmlns:a16="http://schemas.microsoft.com/office/drawing/2014/main" id="{7C1D56CF-AFFC-4BAE-8477-69EEC244CF59}"/>
               </a:ext>
             </a:extLst>
           </p:cNvPr>
@@ -17451,7 +17451,7 @@
           <p:cNvPr id="4" name="">
             <a:extLst xmlns:a="http://schemas.openxmlformats.org/drawingml/2006/main">
               <a:ext uri="{FF2B5EF4-FFF2-40B4-BE49-F238E27FC236}">
-                <a16:creationId xmlns:a16="http://schemas.microsoft.com/office/drawing/2014/main" id="{AA892B77-EAEA-4A22-AF51-59F775F340CE}"/>
+                <a16:creationId xmlns:a16="http://schemas.microsoft.com/office/drawing/2014/main" id="{AB68BE8E-1C24-4A2B-80C8-7C31B7F0DEF7}"/>
               </a:ext>
             </a:extLst>
           </p:cNvPr>
@@ -17846,7 +17846,7 @@
           <p:cNvPr id="5" name="">
             <a:extLst xmlns:a="http://schemas.openxmlformats.org/drawingml/2006/main">
               <a:ext uri="{FF2B5EF4-FFF2-40B4-BE49-F238E27FC236}">
-                <a16:creationId xmlns:a16="http://schemas.microsoft.com/office/drawing/2014/main" id="{6DCC1867-5C31-497F-AE2F-CE73A359D528}"/>
+                <a16:creationId xmlns:a16="http://schemas.microsoft.com/office/drawing/2014/main" id="{5FB50D2E-072B-4D8D-9BD4-558814F5CB4A}"/>
               </a:ext>
             </a:extLst>
           </p:cNvPr>
@@ -17914,7 +17914,7 @@
           <p:cNvPr id="6" name="">
             <a:extLst xmlns:a="http://schemas.openxmlformats.org/drawingml/2006/main">
               <a:ext uri="{FF2B5EF4-FFF2-40B4-BE49-F238E27FC236}">
-                <a16:creationId xmlns:a16="http://schemas.microsoft.com/office/drawing/2014/main" id="{48C80FF8-3CDA-4D77-AE9B-9903E0EC9B05}"/>
+                <a16:creationId xmlns:a16="http://schemas.microsoft.com/office/drawing/2014/main" id="{7E943F56-904B-4204-A7D9-DB41F7EDEB6F}"/>
               </a:ext>
             </a:extLst>
           </p:cNvPr>
@@ -17980,7 +17980,7 @@
     </p:spTree>
     <p:extLst>
       <p:ext uri="{BB962C8B-B14F-4D97-AF65-F5344CB8AC3E}">
-        <p14:creationId xmlns:p14="http://schemas.microsoft.com/office/powerpoint/2010/main" val="1569263379"/>
+        <p14:creationId xmlns:p14="http://schemas.microsoft.com/office/powerpoint/2010/main" val="1894442008"/>
       </p:ext>
     </p:extLst>
   </p:cSld>

</xml_diff>